<commit_message>
docs: refocus intro deck on user benefits for a submissions/deadlines role
Rewrite the deck around the target user — someone juggling many memos with
collections, submissions, and deadlines — instead of implementation
details. Drops the technical "how it works" (agents/JSON-loop) slide and
tech-stack framing; leads with outcomes: scattered memos get organized,
deadlines surface first, and you ask when you can't find something. Now 8
slides, screenshots unchanged.

Co-Authored-By: Claude Fable 5 <noreply@anthropic.com>
</commit_message>
<xml_diff>
--- a/docs/일정아이_소개.pptx
+++ b/docs/일정아이_소개.pptx
@@ -13,10 +13,9 @@
     <p:sldId id="261" r:id="rId7"/>
     <p:sldId id="262" r:id="rId8"/>
     <p:sldId id="263" r:id="rId9"/>
-    <p:sldId id="264" r:id="rId10"/>
   </p:sldIdLst>
   <p:notesMasterIdLst>
-    <p:notesMasterId r:id="rId11"/>
+    <p:notesMasterId r:id="rId10"/>
   </p:notesMasterIdLst>
   <p:sldSz cx="12188952" cy="6858000"/>
   <p:notesSz cx="6858000" cy="12188952"/>
@@ -510,7 +509,7 @@
           <a:p>
             <a:r>
               <a:rPr lang="en-US" dirty="0"/>
-              <a:t>일정아이 소개. 로컬에 저장되고 자연어로 움직이는 업무 플래너. React 19 + TypeScript, Dexie(IndexedDB) 기반 SPA이자 Chrome 확장.</a:t>
+              <a:t>일정아이 — 취합·제출·마감이 많은 사람을 위한 업무 플래너. 흩어진 쪽지를 정리하고, 마감을 먼저 보여 주고, 자연어로 일정을 넣는다.</a:t>
             </a:r>
             <a:endParaRPr lang="en-US" dirty="0"/>
           </a:p>
@@ -598,7 +597,7 @@
           <a:p>
             <a:r>
               <a:rPr lang="en-US" dirty="0"/>
-              <a:t>실제 업무의 통증 4가지를 짚고, 해법의 한 줄 요약으로 넘어간다.</a:t>
+              <a:t>대상 사용자의 하루 통증 4가지 → 해법 한 줄로 연결.</a:t>
             </a:r>
             <a:endParaRPr lang="en-US" dirty="0"/>
           </a:p>
@@ -686,7 +685,7 @@
           <a:p>
             <a:r>
               <a:rPr lang="en-US" dirty="0"/>
-              <a:t>대시보드 월간 보기. 상태별 색 구분, 날짜 클릭 시 그 날 일정, 우클릭 빠른 처리.</a:t>
+              <a:t>대시보드: 마감·제출이 달력에 표식으로, 날짜 클릭 시 그날 할 일, 상태로 구분.</a:t>
             </a:r>
             <a:endParaRPr lang="en-US" dirty="0"/>
           </a:p>
@@ -774,7 +773,7 @@
           <a:p>
             <a:r>
               <a:rPr lang="en-US" dirty="0"/>
-              <a:t>마크다운 노트, 자동 제목/분류, 스택 이어보기, 자동 저장, 일정 연결.</a:t>
+              <a:t>노트: 자동 분류, 취합 체크리스트(+전체 모아보기), 자동 저장, 이어 보기.</a:t>
             </a:r>
             <a:endParaRPr lang="en-US" dirty="0"/>
           </a:p>
@@ -862,7 +861,7 @@
           <a:p>
             <a:r>
               <a:rPr lang="en-US" dirty="0"/>
-              <a:t>자연어 → 초안(바로 저장 안 함) + 재사용 규칙 제안. 규칙은 user.md에 저장되어 자동 적용.</a:t>
+              <a:t>자연어로 일정 입력 → 초안 먼저 확인 → 적용. 반복되는 마감 기준은 규칙으로 학습.</a:t>
             </a:r>
             <a:endParaRPr lang="en-US" dirty="0"/>
           </a:p>
@@ -950,7 +949,7 @@
           <a:p>
             <a:r>
               <a:rPr lang="en-US" dirty="0"/>
-              <a:t>Q&amp;A: 검색해서 답, 참고 칩으로 이동, 도구 호출 내역 표시. 제목 카탈로그를 함께 실어 도구 없이도 답 가능.</a:t>
+              <a:t>질문 기능: 메모·일정을 검색해 답하고, 근거 항목으로 바로 이동.</a:t>
             </a:r>
             <a:endParaRPr lang="en-US" dirty="0"/>
           </a:p>
@@ -1038,7 +1037,7 @@
           <a:p>
             <a:r>
               <a:rPr lang="en-US" dirty="0"/>
-              <a:t>JSON-in-prompt 방식의 도구 호출 루프(최대 4라운드). 4개 에이전트가 공용 인프라를 공유. 네이티브 function calling 불필요 → 로컬 모델 호환.</a:t>
+              <a:t>내 브라우저 저장(로컬), JSON 백업·복구, 통계로 현황 확인.</a:t>
             </a:r>
             <a:endParaRPr lang="en-US" dirty="0"/>
           </a:p>
@@ -1126,7 +1125,7 @@
           <a:p>
             <a:r>
               <a:rPr lang="en-US" dirty="0"/>
-              <a:t>로컬 우선(IndexedDB), JSON 내보내기/되돌리기, AI 토큰 사용량 집계. 설정의 통계 탭.</a:t>
+              <a:t>클로징: 제품 가치 한 줄과 저장소 링크.</a:t>
             </a:r>
             <a:endParaRPr lang="en-US" dirty="0"/>
           </a:p>
@@ -1150,94 +1149,6 @@
             <a:fld id="{F7021451-1387-4CA6-816F-3879F97B5CBC}" type="slidenum">
               <a:rPr lang="en-US"/>
               <a:t>8</a:t>
-            </a:fld>
-            <a:endParaRPr lang="en-US"/>
-          </a:p>
-        </p:txBody>
-      </p:sp>
-    </p:spTree>
-    <p:extLst>
-      <p:ext uri="{BB962C8B-B14F-4D97-AF65-F5344CB8AC3E}">
-        <p14:creationId xmlns:p14="http://schemas.microsoft.com/office/powerpoint/2010/main" val="1024086991"/>
-      </p:ext>
-    </p:extLst>
-  </p:cSld>
-  <p:clrMapOvr>
-    <a:masterClrMapping/>
-  </p:clrMapOvr>
-</p:notes>
-</file>
-
-<file path=ppt/notesSlides/notesSlide9.xml><?xml version="1.0" encoding="utf-8"?>
-<p:notes xmlns:a="http://schemas.openxmlformats.org/drawingml/2006/main" xmlns:r="http://schemas.openxmlformats.org/officeDocument/2006/relationships" xmlns:p="http://schemas.openxmlformats.org/presentationml/2006/main">
-  <p:cSld>
-    <p:spTree>
-      <p:nvGrpSpPr>
-        <p:cNvPr id="1" name=""/>
-        <p:cNvGrpSpPr/>
-        <p:nvPr/>
-      </p:nvGrpSpPr>
-      <p:grpSpPr>
-        <a:xfrm>
-          <a:off x="0" y="0"/>
-          <a:ext cx="0" cy="0"/>
-          <a:chOff x="0" y="0"/>
-          <a:chExt cx="0" cy="0"/>
-        </a:xfrm>
-      </p:grpSpPr>
-      <p:sp>
-        <p:nvSpPr>
-          <p:cNvPr id="2" name="Slide Image Placeholder 1"/>
-          <p:cNvSpPr>
-            <a:spLocks noGrp="1" noRot="1" noChangeAspect="1"/>
-          </p:cNvSpPr>
-          <p:nvPr>
-            <p:ph type="sldImg"/>
-          </p:nvPr>
-        </p:nvSpPr>
-        <p:spPr/>
-      </p:sp>
-      <p:sp>
-        <p:nvSpPr>
-          <p:cNvPr id="3" name="Notes Placeholder 2"/>
-          <p:cNvSpPr>
-            <a:spLocks noGrp="1"/>
-          </p:cNvSpPr>
-          <p:nvPr>
-            <p:ph type="body" idx="1"/>
-          </p:nvPr>
-        </p:nvSpPr>
-        <p:spPr/>
-        <p:txBody>
-          <a:bodyPr/>
-          <a:lstStyle/>
-          <a:p>
-            <a:r>
-              <a:rPr lang="en-US" dirty="0"/>
-              <a:t>클로징: 제품 철학 한 줄과 저장소 링크.</a:t>
-            </a:r>
-            <a:endParaRPr lang="en-US" dirty="0"/>
-          </a:p>
-        </p:txBody>
-      </p:sp>
-      <p:sp>
-        <p:nvSpPr>
-          <p:cNvPr id="4" name="Slide Number Placeholder 3"/>
-          <p:cNvSpPr>
-            <a:spLocks noGrp="1"/>
-          </p:cNvSpPr>
-          <p:nvPr>
-            <p:ph type="sldNum" sz="quarter" idx="10"/>
-          </p:nvPr>
-        </p:nvSpPr>
-        <p:spPr/>
-        <p:txBody>
-          <a:bodyPr/>
-          <a:lstStyle/>
-          <a:p>
-            <a:fld id="{F7021451-1387-4CA6-816F-3879F97B5CBC}" type="slidenum">
-              <a:rPr lang="en-US"/>
-              <a:t>9</a:t>
             </a:fld>
             <a:endParaRPr lang="en-US"/>
           </a:p>
@@ -1639,7 +1550,7 @@
         </p:nvSpPr>
         <p:spPr>
           <a:xfrm>
-            <a:off x="914400" y="1371600"/>
+            <a:off x="914400" y="1280160"/>
             <a:ext cx="786384" cy="786384"/>
           </a:xfrm>
           <a:prstGeom prst="roundRect">
@@ -1661,7 +1572,7 @@
         </p:nvSpPr>
         <p:spPr>
           <a:xfrm>
-            <a:off x="914400" y="1371600"/>
+            <a:off x="914400" y="1280160"/>
             <a:ext cx="786384" cy="786384"/>
           </a:xfrm>
           <a:prstGeom prst="rect">
@@ -1700,7 +1611,7 @@
         </p:nvSpPr>
         <p:spPr>
           <a:xfrm>
-            <a:off x="868680" y="2514600"/>
+            <a:off x="868680" y="2377440"/>
             <a:ext cx="8229600" cy="1188720"/>
           </a:xfrm>
           <a:prstGeom prst="rect">
@@ -1739,8 +1650,8 @@
         </p:nvSpPr>
         <p:spPr>
           <a:xfrm>
-            <a:off x="914400" y="3703320"/>
-            <a:ext cx="9144000" cy="640080"/>
+            <a:off x="914400" y="3611880"/>
+            <a:ext cx="10058400" cy="640080"/>
           </a:xfrm>
           <a:prstGeom prst="rect">
             <a:avLst/>
@@ -1764,7 +1675,7 @@
                 <a:ea typeface="Malgun Gothic" pitchFamily="34" charset="-122"/>
                 <a:cs typeface="Malgun Gothic" pitchFamily="34" charset="-120"/>
               </a:rPr>
-              <a:t>말하면 정리되는 업무 플래너</a:t>
+              <a:t>흩어진 쪽지와 마감을, 한 곳에서</a:t>
             </a:r>
             <a:endParaRPr lang="en-US" sz="2600" dirty="0"/>
           </a:p>
@@ -1778,8 +1689,8 @@
         </p:nvSpPr>
         <p:spPr>
           <a:xfrm>
-            <a:off x="914400" y="4434840"/>
-            <a:ext cx="8778240" cy="731520"/>
+            <a:off x="914400" y="4389120"/>
+            <a:ext cx="9144000" cy="548640"/>
           </a:xfrm>
           <a:prstGeom prst="rect">
             <a:avLst/>
@@ -1792,13 +1703,10 @@
           <a:lstStyle/>
           <a:p>
             <a:pPr indent="0" marL="0">
-              <a:lnSpc>
-                <a:spcPct val="125000"/>
-              </a:lnSpc>
-              <a:buNone/>
-            </a:pPr>
-            <a:r>
-              <a:rPr lang="en-US" sz="1500" dirty="0">
+              <a:buNone/>
+            </a:pPr>
+            <a:r>
+              <a:rPr lang="en-US" sz="1600" dirty="0">
                 <a:solidFill>
                   <a:srgbClr val="C9C9E8"/>
                 </a:solidFill>
@@ -1806,9 +1714,9 @@
                 <a:ea typeface="Malgun Gothic" pitchFamily="34" charset="-122"/>
                 <a:cs typeface="Malgun Gothic" pitchFamily="34" charset="-120"/>
               </a:rPr>
-              <a:t>달력 · 노트 · 프로젝트를 한곳에서 관리하고, 자연어로 일정을 넣고 내 데이터에 질문하는 로컬 우선 플래너.</a:t>
-            </a:r>
-            <a:endParaRPr lang="en-US" sz="1500" dirty="0"/>
+              <a:t>취합·제출·마감이 많은 하루를 자연어로 정리하는 업무 플래너.</a:t>
+            </a:r>
+            <a:endParaRPr lang="en-US" sz="1600" dirty="0"/>
           </a:p>
         </p:txBody>
       </p:sp>
@@ -1820,8 +1728,8 @@
         </p:nvSpPr>
         <p:spPr>
           <a:xfrm>
-            <a:off x="914400" y="5989320"/>
-            <a:ext cx="8229600" cy="365760"/>
+            <a:off x="914400" y="5943600"/>
+            <a:ext cx="9144000" cy="365760"/>
           </a:xfrm>
           <a:prstGeom prst="rect">
             <a:avLst/>
@@ -1845,7 +1753,7 @@
                 <a:ea typeface="Malgun Gothic" pitchFamily="34" charset="-122"/>
                 <a:cs typeface="Malgun Gothic" pitchFamily="34" charset="-120"/>
               </a:rPr>
-              <a:t>React 19  ·  TypeScript  ·  IndexedDB  ·  Local-first</a:t>
+              <a:t>쪽지 정리   ·   마감 관리   ·   자연어 입력   ·   내 컴퓨터에 보관</a:t>
             </a:r>
             <a:endParaRPr lang="en-US" sz="1250" dirty="0"/>
           </a:p>
@@ -1955,7 +1863,7 @@
                 <a:ea typeface="Malgun Gothic" pitchFamily="34" charset="-122"/>
                 <a:cs typeface="Malgun Gothic" pitchFamily="34" charset="-120"/>
               </a:rPr>
-              <a:t>매번 앱을 옮겨 다니지 않아도</a:t>
+              <a:t>이런 하루, 익숙하신가요</a:t>
             </a:r>
             <a:endParaRPr lang="en-US" sz="3300" dirty="0"/>
           </a:p>
@@ -2038,7 +1946,7 @@
                 <a:ea typeface="Malgun Gothic" pitchFamily="34" charset="-122"/>
                 <a:cs typeface="Malgun Gothic" pitchFamily="34" charset="-120"/>
               </a:rPr>
-              <a:t>성격이 다른 일정이 섞인다</a:t>
+              <a:t>쪽지가 여기저기 흩어진다</a:t>
             </a:r>
             <a:endParaRPr lang="en-US" sz="1700" dirty="0"/>
           </a:p>
@@ -2077,7 +1985,7 @@
                 <a:ea typeface="Malgun Gothic" pitchFamily="34" charset="-122"/>
                 <a:cs typeface="Malgun Gothic" pitchFamily="34" charset="-120"/>
               </a:rPr>
-              <a:t>제출·회의·점심·연가·출장이 뒤섞이면 우선순위를 놓친다.</a:t>
+              <a:t>회의 메모, 취합 요청, 제출 목록이 앱마다 따로 논다.</a:t>
             </a:r>
             <a:endParaRPr lang="en-US" sz="1300" dirty="0"/>
           </a:p>
@@ -2160,7 +2068,7 @@
                 <a:ea typeface="Malgun Gothic" pitchFamily="34" charset="-122"/>
                 <a:cs typeface="Malgun Gothic" pitchFamily="34" charset="-120"/>
               </a:rPr>
-              <a:t>지나간 일이 오늘을 가린다</a:t>
+              <a:t>마감이 코앞인데 안 보인다</a:t>
             </a:r>
             <a:endParaRPr lang="en-US" sz="1700" dirty="0"/>
           </a:p>
@@ -2199,7 +2107,7 @@
                 <a:ea typeface="Malgun Gothic" pitchFamily="34" charset="-122"/>
                 <a:cs typeface="Malgun Gothic" pitchFamily="34" charset="-120"/>
               </a:rPr>
-              <a:t>완료·취소된 일이 지금 할 일 위로 겹쳐 보인다.</a:t>
+              <a:t>무엇부터 급한지 한눈에 들어오지 않는다.</a:t>
             </a:r>
             <a:endParaRPr lang="en-US" sz="1300" dirty="0"/>
           </a:p>
@@ -2282,7 +2190,7 @@
                 <a:ea typeface="Malgun Gothic" pitchFamily="34" charset="-122"/>
                 <a:cs typeface="Malgun Gothic" pitchFamily="34" charset="-120"/>
               </a:rPr>
-              <a:t>같은 규칙을 매번 입력한다</a:t>
+              <a:t>취합하고 제출하길 반복한다</a:t>
             </a:r>
             <a:endParaRPr lang="en-US" sz="1700" dirty="0"/>
           </a:p>
@@ -2321,7 +2229,7 @@
                 <a:ea typeface="Malgun Gothic" pitchFamily="34" charset="-122"/>
                 <a:cs typeface="Malgun Gothic" pitchFamily="34" charset="-120"/>
               </a:rPr>
-              <a:t>"점심은 11:30, 제출은 18:00" 같은 습관을 손으로 반복한다.</a:t>
+              <a:t>여기저기서 받아 모아, 정해진 기한에 낸다.</a:t>
             </a:r>
             <a:endParaRPr lang="en-US" sz="1300" dirty="0"/>
           </a:p>
@@ -2404,7 +2312,7 @@
                 <a:ea typeface="Malgun Gothic" pitchFamily="34" charset="-122"/>
                 <a:cs typeface="Malgun Gothic" pitchFamily="34" charset="-120"/>
               </a:rPr>
-              <a:t>입력 폼은 여전히 번거롭다</a:t>
+              <a:t>"그거 어디 적었더라"</a:t>
             </a:r>
             <a:endParaRPr lang="en-US" sz="1700" dirty="0"/>
           </a:p>
@@ -2443,7 +2351,7 @@
                 <a:ea typeface="Malgun Gothic" pitchFamily="34" charset="-122"/>
                 <a:cs typeface="Malgun Gothic" pitchFamily="34" charset="-120"/>
               </a:rPr>
-              <a:t>"내일 10시에 보고서 제출"이라고 말하고 싶다.</a:t>
+              <a:t>필요할 때마다 메모를 뒤지느라 시간을 쓴다.</a:t>
             </a:r>
             <a:endParaRPr lang="en-US" sz="1300" dirty="0"/>
           </a:p>
@@ -2526,7 +2434,7 @@
         <p:spPr>
           <a:xfrm>
             <a:off x="8412480" y="2834640"/>
-            <a:ext cx="2788920" cy="1554480"/>
+            <a:ext cx="2788920" cy="1920240"/>
           </a:xfrm>
           <a:prstGeom prst="rect">
             <a:avLst/>
@@ -2540,12 +2448,29 @@
           <a:p>
             <a:pPr indent="0" marL="0">
               <a:lnSpc>
-                <a:spcPct val="132000"/>
+                <a:spcPct val="135000"/>
               </a:lnSpc>
               <a:buNone/>
             </a:pPr>
             <a:r>
-              <a:rPr lang="en-US" sz="1700" b="1" dirty="0">
+              <a:rPr lang="en-US" sz="1800" b="1" dirty="0">
+                <a:solidFill>
+                  <a:srgbClr val="26263A"/>
+                </a:solidFill>
+                <a:latin typeface="Malgun Gothic" pitchFamily="34" charset="0"/>
+                <a:ea typeface="Malgun Gothic" pitchFamily="34" charset="-122"/>
+                <a:cs typeface="Malgun Gothic" pitchFamily="34" charset="-120"/>
+              </a:rPr>
+              <a:t>쪽지는 </a:t>
+            </a:r>
+            <a:pPr indent="0" marL="0">
+              <a:lnSpc>
+                <a:spcPct val="135000"/>
+              </a:lnSpc>
+              <a:buNone/>
+            </a:pPr>
+            <a:r>
+              <a:rPr lang="en-US" sz="1800" b="1" dirty="0">
                 <a:solidFill>
                   <a:srgbClr val="6C5CE7"/>
                 </a:solidFill>
@@ -2553,16 +2478,19 @@
                 <a:ea typeface="Malgun Gothic" pitchFamily="34" charset="-122"/>
                 <a:cs typeface="Malgun Gothic" pitchFamily="34" charset="-120"/>
               </a:rPr>
-              <a:t>말하면 </a:t>
-            </a:r>
+              <a:t>정리되고,</a:t>
+            </a:r>
+            <a:endParaRPr lang="en-US" sz="1800" dirty="0"/>
+          </a:p>
+          <a:p>
             <a:pPr indent="0" marL="0">
               <a:lnSpc>
-                <a:spcPct val="132000"/>
+                <a:spcPct val="135000"/>
               </a:lnSpc>
               <a:buNone/>
             </a:pPr>
             <a:r>
-              <a:rPr lang="en-US" sz="1700" b="1" dirty="0">
+              <a:rPr lang="en-US" sz="1800" b="1" dirty="0">
                 <a:solidFill>
                   <a:srgbClr val="26263A"/>
                 </a:solidFill>
@@ -2570,19 +2498,16 @@
                 <a:ea typeface="Malgun Gothic" pitchFamily="34" charset="-122"/>
                 <a:cs typeface="Malgun Gothic" pitchFamily="34" charset="-120"/>
               </a:rPr>
-              <a:t>초안이 나오고,</a:t>
-            </a:r>
-            <a:endParaRPr lang="en-US" sz="1700" dirty="0"/>
-          </a:p>
-          <a:p>
+              <a:t>마감은 </a:t>
+            </a:r>
             <a:pPr indent="0" marL="0">
               <a:lnSpc>
-                <a:spcPct val="132000"/>
+                <a:spcPct val="135000"/>
               </a:lnSpc>
               <a:buNone/>
             </a:pPr>
             <a:r>
-              <a:rPr lang="en-US" sz="1700" b="1" dirty="0">
+              <a:rPr lang="en-US" sz="1800" b="1" dirty="0">
                 <a:solidFill>
                   <a:srgbClr val="6C5CE7"/>
                 </a:solidFill>
@@ -2590,16 +2515,19 @@
                 <a:ea typeface="Malgun Gothic" pitchFamily="34" charset="-122"/>
                 <a:cs typeface="Malgun Gothic" pitchFamily="34" charset="-120"/>
               </a:rPr>
-              <a:t>반복은 </a:t>
-            </a:r>
+              <a:t>먼저 보이고,</a:t>
+            </a:r>
+            <a:endParaRPr lang="en-US" sz="1800" dirty="0"/>
+          </a:p>
+          <a:p>
             <a:pPr indent="0" marL="0">
               <a:lnSpc>
-                <a:spcPct val="132000"/>
+                <a:spcPct val="135000"/>
               </a:lnSpc>
               <a:buNone/>
             </a:pPr>
             <a:r>
-              <a:rPr lang="en-US" sz="1700" b="1" dirty="0">
+              <a:rPr lang="en-US" sz="1800" b="1" dirty="0">
                 <a:solidFill>
                   <a:srgbClr val="26263A"/>
                 </a:solidFill>
@@ -2607,48 +2535,26 @@
                 <a:ea typeface="Malgun Gothic" pitchFamily="34" charset="-122"/>
                 <a:cs typeface="Malgun Gothic" pitchFamily="34" charset="-120"/>
               </a:rPr>
-              <a:t>스스로 규칙이 된다.</a:t>
-            </a:r>
-            <a:endParaRPr lang="en-US" sz="1700" dirty="0"/>
-          </a:p>
-        </p:txBody>
-      </p:sp>
-      <p:sp>
-        <p:nvSpPr>
-          <p:cNvPr id="23" name="Text 17"/>
-          <p:cNvSpPr/>
-          <p:nvPr/>
-        </p:nvSpPr>
-        <p:spPr>
-          <a:xfrm>
-            <a:off x="8412480" y="4892040"/>
-            <a:ext cx="2788920" cy="457200"/>
-          </a:xfrm>
-          <a:prstGeom prst="rect">
-            <a:avLst/>
-          </a:prstGeom>
-          <a:noFill/>
-          <a:ln/>
-        </p:spPr>
-        <p:txBody>
-          <a:bodyPr wrap="square" lIns="0" tIns="0" rIns="0" bIns="0" rtlCol="0" anchor="ctr"/>
-          <a:lstStyle/>
-          <a:p>
-            <a:pPr indent="0" marL="0">
-              <a:buNone/>
-            </a:pPr>
-            <a:r>
-              <a:rPr lang="en-US" sz="1200" dirty="0">
-                <a:solidFill>
-                  <a:srgbClr val="6E6E82"/>
-                </a:solidFill>
-                <a:latin typeface="Malgun Gothic" pitchFamily="34" charset="0"/>
-                <a:ea typeface="Malgun Gothic" pitchFamily="34" charset="-122"/>
-                <a:cs typeface="Malgun Gothic" pitchFamily="34" charset="-120"/>
-              </a:rPr>
-              <a:t>확인하고 적용하는 흐름은 그대로.</a:t>
-            </a:r>
-            <a:endParaRPr lang="en-US" sz="1200" dirty="0"/>
+              <a:t>찾을 땐 </a:t>
+            </a:r>
+            <a:pPr indent="0" marL="0">
+              <a:lnSpc>
+                <a:spcPct val="135000"/>
+              </a:lnSpc>
+              <a:buNone/>
+            </a:pPr>
+            <a:r>
+              <a:rPr lang="en-US" sz="1800" b="1" dirty="0">
+                <a:solidFill>
+                  <a:srgbClr val="6C5CE7"/>
+                </a:solidFill>
+                <a:latin typeface="Malgun Gothic" pitchFamily="34" charset="0"/>
+                <a:ea typeface="Malgun Gothic" pitchFamily="34" charset="-122"/>
+                <a:cs typeface="Malgun Gothic" pitchFamily="34" charset="-120"/>
+              </a:rPr>
+              <a:t>물어본다.</a:t>
+            </a:r>
+            <a:endParaRPr lang="en-US" sz="1800" dirty="0"/>
           </a:p>
         </p:txBody>
       </p:sp>
@@ -2717,7 +2623,7 @@
                 <a:ea typeface="Malgun Gothic" pitchFamily="34" charset="-122"/>
                 <a:cs typeface="Malgun Gothic" pitchFamily="34" charset="-120"/>
               </a:rPr>
-              <a:t>DASHBOARD</a:t>
+              <a:t>한눈에</a:t>
             </a:r>
             <a:endParaRPr lang="en-US" sz="1100" dirty="0"/>
           </a:p>
@@ -2756,7 +2662,7 @@
                 <a:ea typeface="Malgun Gothic" pitchFamily="34" charset="-122"/>
                 <a:cs typeface="Malgun Gothic" pitchFamily="34" charset="-120"/>
               </a:rPr>
-              <a:t>이번 달을 한 장에</a:t>
+              <a:t>오늘 뭐가 급한지, 한눈에</a:t>
             </a:r>
             <a:endParaRPr lang="en-US" sz="3200" dirty="0"/>
           </a:p>
@@ -2897,7 +2803,7 @@
                 <a:ea typeface="Malgun Gothic" pitchFamily="34" charset="-122"/>
                 <a:cs typeface="Malgun Gothic" pitchFamily="34" charset="-120"/>
               </a:rPr>
-              <a:t>상태로 구분</a:t>
+              <a:t>마감·제출이 달력에</a:t>
             </a:r>
             <a:endParaRPr lang="en-US" sz="1600" dirty="0"/>
           </a:p>
@@ -2939,7 +2845,7 @@
                 <a:ea typeface="Malgun Gothic" pitchFamily="34" charset="-122"/>
                 <a:cs typeface="Malgun Gothic" pitchFamily="34" charset="-120"/>
               </a:rPr>
-              <a:t>미완료는 또렷하게, 완료·취소는 흐리게. 연가는 초록, 출장은 파랑으로 셀이 물든다.</a:t>
+              <a:t>제출·중요 표식으로 급한 날이 먼저 눈에 띈다. 연가·출장도 셀 색으로 구분.</a:t>
             </a:r>
             <a:endParaRPr lang="en-US" sz="1250" dirty="0"/>
           </a:p>
@@ -3064,7 +2970,7 @@
                 <a:ea typeface="Malgun Gothic" pitchFamily="34" charset="-122"/>
                 <a:cs typeface="Malgun Gothic" pitchFamily="34" charset="-120"/>
               </a:rPr>
-              <a:t>달력과 메모 사이에 그 날 일정만 목록으로. 상태 배지가 곧 필터.</a:t>
+              <a:t>그 날 해야 할 일만 목록으로. 남은 것부터 위로 올라온다.</a:t>
             </a:r>
             <a:endParaRPr lang="en-US" sz="1250" dirty="0"/>
           </a:p>
@@ -3147,7 +3053,7 @@
                 <a:ea typeface="Malgun Gothic" pitchFamily="34" charset="-122"/>
                 <a:cs typeface="Malgun Gothic" pitchFamily="34" charset="-120"/>
               </a:rPr>
-              <a:t>우클릭으로 빠르게</a:t>
+              <a:t>끝낸 일은 흐리게</a:t>
             </a:r>
             <a:endParaRPr lang="en-US" sz="1600" dirty="0"/>
           </a:p>
@@ -3189,7 +3095,7 @@
                 <a:ea typeface="Malgun Gothic" pitchFamily="34" charset="-122"/>
                 <a:cs typeface="Malgun Gothic" pitchFamily="34" charset="-120"/>
               </a:rPr>
-              <a:t>완료·보류·수정·복제·삭제와 연가 설정을 달력에서 바로.</a:t>
+              <a:t>완료·취소는 가라앉고, 남은 일만 또렷하게 남는다.</a:t>
             </a:r>
             <a:endParaRPr lang="en-US" sz="1250" dirty="0"/>
           </a:p>
@@ -3260,7 +3166,7 @@
                 <a:ea typeface="Malgun Gothic" pitchFamily="34" charset="-122"/>
                 <a:cs typeface="Malgun Gothic" pitchFamily="34" charset="-120"/>
               </a:rPr>
-              <a:t>NOTES</a:t>
+              <a:t>쪽지</a:t>
             </a:r>
             <a:endParaRPr lang="en-US" sz="1100" dirty="0"/>
           </a:p>
@@ -3299,7 +3205,7 @@
                 <a:ea typeface="Malgun Gothic" pitchFamily="34" charset="-122"/>
                 <a:cs typeface="Malgun Gothic" pitchFamily="34" charset="-120"/>
               </a:rPr>
-              <a:t>쓰고, 묶고, 이어 보기</a:t>
+              <a:t>흩어진 쪽지를, 쌓아서 쓴다</a:t>
             </a:r>
             <a:endParaRPr lang="en-US" sz="3200" dirty="0"/>
           </a:p>
@@ -3440,7 +3346,7 @@
                 <a:ea typeface="Malgun Gothic" pitchFamily="34" charset="-122"/>
                 <a:cs typeface="Malgun Gothic" pitchFamily="34" charset="-120"/>
               </a:rPr>
-              <a:t>자동 제목·분류</a:t>
+              <a:t>알아서 분류된다</a:t>
             </a:r>
             <a:endParaRPr lang="en-US" sz="1600" dirty="0"/>
           </a:p>
@@ -3482,7 +3388,7 @@
                 <a:ea typeface="Malgun Gothic" pitchFamily="34" charset="-122"/>
                 <a:cs typeface="Malgun Gothic" pitchFamily="34" charset="-120"/>
               </a:rPr>
-              <a:t>본문 첫 줄에서 제목을 따오고, 프로젝트·세부 항목을 백그라운드에서 추천.</a:t>
+              <a:t>새 쪽지를 프로젝트·주제별로 자동으로 묶어, 뒤질 일이 줄어든다.</a:t>
             </a:r>
             <a:endParaRPr lang="en-US" sz="1250" dirty="0"/>
           </a:p>
@@ -3565,7 +3471,7 @@
                 <a:ea typeface="Malgun Gothic" pitchFamily="34" charset="-122"/>
                 <a:cs typeface="Malgun Gothic" pitchFamily="34" charset="-120"/>
               </a:rPr>
-              <a:t>이어 보기</a:t>
+              <a:t>취합은 체크리스트로</a:t>
             </a:r>
             <a:endParaRPr lang="en-US" sz="1600" dirty="0"/>
           </a:p>
@@ -3607,7 +3513,7 @@
                 <a:ea typeface="Malgun Gothic" pitchFamily="34" charset="-122"/>
                 <a:cs typeface="Malgun Gothic" pitchFamily="34" charset="-120"/>
               </a:rPr>
-              <a:t>카테고리를 고르면 노트가 위아래로 펼쳐지고, 체크박스는 그 자리에서 토글.</a:t>
+              <a:t>받을 항목을 체크하며 관리하고, 남은 건 한 곳에 모아 본다.</a:t>
             </a:r>
             <a:endParaRPr lang="en-US" sz="1250" dirty="0"/>
           </a:p>
@@ -3690,7 +3596,7 @@
                 <a:ea typeface="Malgun Gothic" pitchFamily="34" charset="-122"/>
                 <a:cs typeface="Malgun Gothic" pitchFamily="34" charset="-120"/>
               </a:rPr>
-              <a:t>잃지 않는 편집</a:t>
+              <a:t>놓치지 않는 저장</a:t>
             </a:r>
             <a:endParaRPr lang="en-US" sz="1600" dirty="0"/>
           </a:p>
@@ -3732,7 +3638,7 @@
                 <a:ea typeface="Malgun Gothic" pitchFamily="34" charset="-122"/>
                 <a:cs typeface="Malgun Gothic" pitchFamily="34" charset="-120"/>
               </a:rPr>
-              <a:t>카드를 끌어 순서를 바꾸고, 다른 노트로 넘어가도 자동 저장.</a:t>
+              <a:t>다른 쪽지로 넘어가도 자동 저장, 순서도 끌어서 바꾼다.</a:t>
             </a:r>
             <a:endParaRPr lang="en-US" sz="1250" dirty="0"/>
           </a:p>
@@ -3803,7 +3709,7 @@
                 <a:ea typeface="Malgun Gothic" pitchFamily="34" charset="-122"/>
                 <a:cs typeface="Malgun Gothic" pitchFamily="34" charset="-120"/>
               </a:rPr>
-              <a:t>AI SCHEDULE</a:t>
+              <a:t>빠른 입력</a:t>
             </a:r>
             <a:endParaRPr lang="en-US" sz="1100" dirty="0"/>
           </a:p>
@@ -3842,7 +3748,7 @@
                 <a:ea typeface="Malgun Gothic" pitchFamily="34" charset="-122"/>
                 <a:cs typeface="Malgun Gothic" pitchFamily="34" charset="-120"/>
               </a:rPr>
-              <a:t>자연어 한 줄이면 초안이 나온다</a:t>
+              <a:t>말하면, 일정이 된다</a:t>
             </a:r>
             <a:endParaRPr lang="en-US" sz="3100" dirty="0"/>
           </a:p>
@@ -3929,7 +3835,7 @@
                 <a:ea typeface="Malgun Gothic" pitchFamily="34" charset="-122"/>
                 <a:cs typeface="Malgun Gothic" pitchFamily="34" charset="-120"/>
               </a:rPr>
-              <a:t>내일 11시반에 김선임과 점심</a:t>
+              <a:t>금요일까지 실적보고 제출 잡아줘</a:t>
             </a:r>
             <a:pPr indent="0" marL="0">
               <a:buNone/>
@@ -3985,7 +3891,7 @@
                 <a:ea typeface="Malgun Gothic" pitchFamily="34" charset="-122"/>
                 <a:cs typeface="Malgun Gothic" pitchFamily="34" charset="-120"/>
               </a:rPr>
-              <a:t>AI는 바로 저장하지 않는다.</a:t>
+              <a:t>날짜·마감·종류를 알아서 채운다.</a:t>
             </a:r>
             <a:endParaRPr lang="en-US" sz="1450" dirty="0"/>
           </a:p>
@@ -4005,7 +3911,7 @@
                 <a:ea typeface="Malgun Gothic" pitchFamily="34" charset="-122"/>
                 <a:cs typeface="Malgun Gothic" pitchFamily="34" charset="-120"/>
               </a:rPr>
-              <a:t>날짜·시간·프로젝트·종류를 채운 초안을 먼저 보여 주고, 확인해서 적용한다.</a:t>
+              <a:t>바로 저장하지 않고 초안을 먼저 보여 주니, 확인하고 넣으면 끝.</a:t>
             </a:r>
             <a:endParaRPr lang="en-US" sz="1450" dirty="0"/>
           </a:p>
@@ -4066,7 +3972,7 @@
                 <a:ea typeface="Malgun Gothic" pitchFamily="34" charset="-122"/>
                 <a:cs typeface="Malgun Gothic" pitchFamily="34" charset="-120"/>
               </a:rPr>
-              <a:t>반복되는 습관은 규칙이 된다</a:t>
+              <a:t>반복되는 기준은 기억한다</a:t>
             </a:r>
             <a:endParaRPr lang="en-US" sz="1600" dirty="0"/>
           </a:p>
@@ -4108,7 +4014,7 @@
                 <a:ea typeface="Malgun Gothic" pitchFamily="34" charset="-122"/>
                 <a:cs typeface="Malgun Gothic" pitchFamily="34" charset="-120"/>
               </a:rPr>
-              <a:t>"점심은 11시반, 점심 약속 프로젝트" 같은 패턴을 </a:t>
+              <a:t>"제출은 오후 6시, 점심은 11시반" 처럼 늘 쓰는 기준을 </a:t>
             </a:r>
             <a:pPr indent="0" marL="0">
               <a:lnSpc>
@@ -4125,7 +4031,7 @@
                 <a:ea typeface="Malgun Gothic" pitchFamily="34" charset="-122"/>
                 <a:cs typeface="Malgun Gothic" pitchFamily="34" charset="-120"/>
               </a:rPr>
-              <a:t>재사용 규칙</a:t>
+              <a:t>규칙으로 저장</a:t>
             </a:r>
             <a:pPr indent="0" marL="0">
               <a:lnSpc>
@@ -4142,41 +4048,7 @@
                 <a:ea typeface="Malgun Gothic" pitchFamily="34" charset="-122"/>
                 <a:cs typeface="Malgun Gothic" pitchFamily="34" charset="-120"/>
               </a:rPr>
-              <a:t>으로 제안한다. 규칙을 먼저 검토·저장하면 </a:t>
-            </a:r>
-            <a:pPr indent="0" marL="0">
-              <a:lnSpc>
-                <a:spcPct val="128000"/>
-              </a:lnSpc>
-              <a:buNone/>
-            </a:pPr>
-            <a:r>
-              <a:rPr lang="en-US" sz="1300" b="1" dirty="0">
-                <a:solidFill>
-                  <a:srgbClr val="4A3FB5"/>
-                </a:solidFill>
-                <a:latin typeface="Malgun Gothic" pitchFamily="34" charset="0"/>
-                <a:ea typeface="Malgun Gothic" pitchFamily="34" charset="-122"/>
-                <a:cs typeface="Malgun Gothic" pitchFamily="34" charset="-120"/>
-              </a:rPr>
-              <a:t>user.md</a:t>
-            </a:r>
-            <a:pPr indent="0" marL="0">
-              <a:lnSpc>
-                <a:spcPct val="128000"/>
-              </a:lnSpc>
-              <a:buNone/>
-            </a:pPr>
-            <a:r>
-              <a:rPr lang="en-US" sz="1300" dirty="0">
-                <a:solidFill>
-                  <a:srgbClr val="26263A"/>
-                </a:solidFill>
-                <a:latin typeface="Malgun Gothic" pitchFamily="34" charset="0"/>
-                <a:ea typeface="Malgun Gothic" pitchFamily="34" charset="-122"/>
-                <a:cs typeface="Malgun Gothic" pitchFamily="34" charset="-120"/>
-              </a:rPr>
-              <a:t>에 남아 다음부터 자동 적용.</a:t>
+              <a:t>해 두면, 다음부터는 시간을 말하지 않아도 알아서 채워 준다.</a:t>
             </a:r>
             <a:endParaRPr lang="en-US" sz="1300" dirty="0"/>
           </a:p>
@@ -4305,7 +4177,7 @@
                 <a:ea typeface="Malgun Gothic" pitchFamily="34" charset="-122"/>
                 <a:cs typeface="Malgun Gothic" pitchFamily="34" charset="-120"/>
               </a:rPr>
-              <a:t>ASK YOUR DATA</a:t>
+              <a:t>찾기</a:t>
             </a:r>
             <a:endParaRPr lang="en-US" sz="1100" dirty="0"/>
           </a:p>
@@ -4320,7 +4192,7 @@
         <p:spPr>
           <a:xfrm>
             <a:off x="7360920" y="914400"/>
-            <a:ext cx="4389120" cy="1097280"/>
+            <a:ext cx="4389120" cy="1188720"/>
           </a:xfrm>
           <a:prstGeom prst="rect">
             <a:avLst/>
@@ -4334,12 +4206,12 @@
           <a:p>
             <a:pPr indent="0" marL="0">
               <a:lnSpc>
-                <a:spcPct val="105000"/>
+                <a:spcPct val="110000"/>
               </a:lnSpc>
               <a:buNone/>
             </a:pPr>
             <a:r>
-              <a:rPr lang="en-US" sz="2800" b="1" dirty="0">
+              <a:rPr lang="en-US" sz="2700" b="1" dirty="0">
                 <a:solidFill>
                   <a:srgbClr val="26263A"/>
                 </a:solidFill>
@@ -4347,9 +4219,29 @@
                 <a:ea typeface="Malgun Gothic" pitchFamily="34" charset="-122"/>
                 <a:cs typeface="Malgun Gothic" pitchFamily="34" charset="-120"/>
               </a:rPr>
-              <a:t>내 노트와 일정에 물어보기</a:t>
-            </a:r>
-            <a:endParaRPr lang="en-US" sz="2800" dirty="0"/>
+              <a:t>"어디 적었더라?"</a:t>
+            </a:r>
+            <a:endParaRPr lang="en-US" sz="2700" dirty="0"/>
+          </a:p>
+          <a:p>
+            <a:pPr indent="0" marL="0">
+              <a:lnSpc>
+                <a:spcPct val="110000"/>
+              </a:lnSpc>
+              <a:buNone/>
+            </a:pPr>
+            <a:r>
+              <a:rPr lang="en-US" sz="2700" b="1" dirty="0">
+                <a:solidFill>
+                  <a:srgbClr val="26263A"/>
+                </a:solidFill>
+                <a:latin typeface="Malgun Gothic" pitchFamily="34" charset="0"/>
+                <a:ea typeface="Malgun Gothic" pitchFamily="34" charset="-122"/>
+                <a:cs typeface="Malgun Gothic" pitchFamily="34" charset="-120"/>
+              </a:rPr>
+              <a:t>물어보면 찾아준다</a:t>
+            </a:r>
+            <a:endParaRPr lang="en-US" sz="2700" dirty="0"/>
           </a:p>
         </p:txBody>
       </p:sp>
@@ -4361,12 +4253,12 @@
         </p:nvSpPr>
         <p:spPr>
           <a:xfrm>
-            <a:off x="768096" y="1179576"/>
-            <a:ext cx="6298387" cy="4407408"/>
+            <a:off x="768096" y="1316736"/>
+            <a:ext cx="6166714" cy="4315968"/>
           </a:xfrm>
           <a:prstGeom prst="roundRect">
             <a:avLst>
-              <a:gd name="adj" fmla="val 1867"/>
+              <a:gd name="adj" fmla="val 1907"/>
             </a:avLst>
           </a:prstGeom>
           <a:solidFill>
@@ -4403,8 +4295,8 @@
         </p:blipFill>
         <p:spPr>
           <a:xfrm>
-            <a:off x="822960" y="1234440"/>
-            <a:ext cx="6188659" cy="4297680"/>
+            <a:off x="822960" y="1371600"/>
+            <a:ext cx="6056986" cy="4206240"/>
           </a:xfrm>
           <a:prstGeom prst="rect">
             <a:avLst/>
@@ -4419,7 +4311,7 @@
         </p:nvSpPr>
         <p:spPr>
           <a:xfrm>
-            <a:off x="7360920" y="2212848"/>
+            <a:off x="7360920" y="2487168"/>
             <a:ext cx="310896" cy="310896"/>
           </a:xfrm>
           <a:prstGeom prst="ellipse">
@@ -4447,7 +4339,7 @@
         </p:blipFill>
         <p:spPr>
           <a:xfrm>
-            <a:off x="7441753" y="2293681"/>
+            <a:off x="7441753" y="2568001"/>
             <a:ext cx="149230" cy="149230"/>
           </a:xfrm>
           <a:prstGeom prst="rect">
@@ -4463,7 +4355,7 @@
         </p:nvSpPr>
         <p:spPr>
           <a:xfrm>
-            <a:off x="7799832" y="2148840"/>
+            <a:off x="7799832" y="2423160"/>
             <a:ext cx="4023360" cy="365760"/>
           </a:xfrm>
           <a:prstGeom prst="rect">
@@ -4480,7 +4372,7 @@
               <a:buNone/>
             </a:pPr>
             <a:r>
-              <a:rPr lang="en-US" sz="1600" b="1" dirty="0">
+              <a:rPr lang="en-US" sz="1550" b="1" dirty="0">
                 <a:solidFill>
                   <a:srgbClr val="26263A"/>
                 </a:solidFill>
@@ -4488,9 +4380,9 @@
                 <a:ea typeface="Malgun Gothic" pitchFamily="34" charset="-122"/>
                 <a:cs typeface="Malgun Gothic" pitchFamily="34" charset="-120"/>
               </a:rPr>
-              <a:t>검색해서 답한다</a:t>
-            </a:r>
-            <a:endParaRPr lang="en-US" sz="1600" dirty="0"/>
+              <a:t>메모와 일정을 뒤져 답한다</a:t>
+            </a:r>
+            <a:endParaRPr lang="en-US" sz="1550" dirty="0"/>
           </a:p>
         </p:txBody>
       </p:sp>
@@ -4502,7 +4394,7 @@
         </p:nvSpPr>
         <p:spPr>
           <a:xfrm>
-            <a:off x="7799832" y="2514600"/>
+            <a:off x="7799832" y="2788920"/>
             <a:ext cx="4114800" cy="640080"/>
           </a:xfrm>
           <a:prstGeom prst="rect">
@@ -4530,7 +4422,7 @@
                 <a:ea typeface="Malgun Gothic" pitchFamily="34" charset="-122"/>
                 <a:cs typeface="Malgun Gothic" pitchFamily="34" charset="-120"/>
               </a:rPr>
-              <a:t>노트와 일정을 뒤져 근거 있는 답을 만든다.</a:t>
+              <a:t>"표준특허 관련 정리한 거" 한 줄이면 찾아 준다.</a:t>
             </a:r>
             <a:endParaRPr lang="en-US" sz="1250" dirty="0"/>
           </a:p>
@@ -4544,7 +4436,7 @@
         </p:nvSpPr>
         <p:spPr>
           <a:xfrm>
-            <a:off x="7360920" y="3383280"/>
+            <a:off x="7360920" y="3630168"/>
             <a:ext cx="310896" cy="310896"/>
           </a:xfrm>
           <a:prstGeom prst="ellipse">
@@ -4572,7 +4464,7 @@
         </p:blipFill>
         <p:spPr>
           <a:xfrm>
-            <a:off x="7441753" y="3464113"/>
+            <a:off x="7441753" y="3711001"/>
             <a:ext cx="149230" cy="149230"/>
           </a:xfrm>
           <a:prstGeom prst="rect">
@@ -4588,7 +4480,7 @@
         </p:nvSpPr>
         <p:spPr>
           <a:xfrm>
-            <a:off x="7799832" y="3319272"/>
+            <a:off x="7799832" y="3566160"/>
             <a:ext cx="4023360" cy="365760"/>
           </a:xfrm>
           <a:prstGeom prst="rect">
@@ -4605,7 +4497,7 @@
               <a:buNone/>
             </a:pPr>
             <a:r>
-              <a:rPr lang="en-US" sz="1600" b="1" dirty="0">
+              <a:rPr lang="en-US" sz="1550" b="1" dirty="0">
                 <a:solidFill>
                   <a:srgbClr val="26263A"/>
                 </a:solidFill>
@@ -4613,9 +4505,9 @@
                 <a:ea typeface="Malgun Gothic" pitchFamily="34" charset="-122"/>
                 <a:cs typeface="Malgun Gothic" pitchFamily="34" charset="-120"/>
               </a:rPr>
-              <a:t>참고 칩으로 이동</a:t>
-            </a:r>
-            <a:endParaRPr lang="en-US" sz="1600" dirty="0"/>
+              <a:t>바로 그 화면으로</a:t>
+            </a:r>
+            <a:endParaRPr lang="en-US" sz="1550" dirty="0"/>
           </a:p>
         </p:txBody>
       </p:sp>
@@ -4627,7 +4519,7 @@
         </p:nvSpPr>
         <p:spPr>
           <a:xfrm>
-            <a:off x="7799832" y="3685032"/>
+            <a:off x="7799832" y="3931920"/>
             <a:ext cx="4114800" cy="640080"/>
           </a:xfrm>
           <a:prstGeom prst="rect">
@@ -4655,7 +4547,7 @@
                 <a:ea typeface="Malgun Gothic" pitchFamily="34" charset="-122"/>
                 <a:cs typeface="Malgun Gothic" pitchFamily="34" charset="-120"/>
               </a:rPr>
-              <a:t>근거가 된 노트·일정을 눌러 바로 그 화면으로.</a:t>
+              <a:t>찾은 메모·일정을 눌러 곧장 이동한다.</a:t>
             </a:r>
             <a:endParaRPr lang="en-US" sz="1250" dirty="0"/>
           </a:p>
@@ -4669,7 +4561,7 @@
         </p:nvSpPr>
         <p:spPr>
           <a:xfrm>
-            <a:off x="7360920" y="4553712"/>
+            <a:off x="7360920" y="4773168"/>
             <a:ext cx="310896" cy="310896"/>
           </a:xfrm>
           <a:prstGeom prst="ellipse">
@@ -4697,7 +4589,7 @@
         </p:blipFill>
         <p:spPr>
           <a:xfrm>
-            <a:off x="7441753" y="4634545"/>
+            <a:off x="7441753" y="4854001"/>
             <a:ext cx="149230" cy="149230"/>
           </a:xfrm>
           <a:prstGeom prst="rect">
@@ -4713,7 +4605,7 @@
         </p:nvSpPr>
         <p:spPr>
           <a:xfrm>
-            <a:off x="7799832" y="4489704"/>
+            <a:off x="7799832" y="4709160"/>
             <a:ext cx="4023360" cy="365760"/>
           </a:xfrm>
           <a:prstGeom prst="rect">
@@ -4730,7 +4622,7 @@
               <a:buNone/>
             </a:pPr>
             <a:r>
-              <a:rPr lang="en-US" sz="1600" b="1" dirty="0">
+              <a:rPr lang="en-US" sz="1550" b="1" dirty="0">
                 <a:solidFill>
                   <a:srgbClr val="26263A"/>
                 </a:solidFill>
@@ -4738,9 +4630,9 @@
                 <a:ea typeface="Malgun Gothic" pitchFamily="34" charset="-122"/>
                 <a:cs typeface="Malgun Gothic" pitchFamily="34" charset="-120"/>
               </a:rPr>
-              <a:t>도구 호출을 투명하게</a:t>
-            </a:r>
-            <a:endParaRPr lang="en-US" sz="1600" dirty="0"/>
+              <a:t>근거도 같이 보여 준다</a:t>
+            </a:r>
+            <a:endParaRPr lang="en-US" sz="1550" dirty="0"/>
           </a:p>
         </p:txBody>
       </p:sp>
@@ -4752,7 +4644,7 @@
         </p:nvSpPr>
         <p:spPr>
           <a:xfrm>
-            <a:off x="7799832" y="4855464"/>
+            <a:off x="7799832" y="5074920"/>
             <a:ext cx="4114800" cy="640080"/>
           </a:xfrm>
           <a:prstGeom prst="rect">
@@ -4780,7 +4672,7 @@
                 <a:ea typeface="Malgun Gothic" pitchFamily="34" charset="-122"/>
                 <a:cs typeface="Malgun Gothic" pitchFamily="34" charset="-120"/>
               </a:rPr>
-              <a:t>🔎 줄이 어떤 검색을 몇 번 했는지 보여 준다.</a:t>
+              <a:t>어디서 찾았는지 함께 확인할 수 있다.</a:t>
             </a:r>
             <a:endParaRPr lang="en-US" sz="1250" dirty="0"/>
           </a:p>
@@ -4797,6 +4689,606 @@
 <file path=ppt/slides/slide7.xml><?xml version="1.0" encoding="utf-8"?>
 <p:sld xmlns:a="http://schemas.openxmlformats.org/drawingml/2006/main" xmlns:r="http://schemas.openxmlformats.org/officeDocument/2006/relationships" xmlns:p="http://schemas.openxmlformats.org/presentationml/2006/main">
   <p:cSld name="Slide 7">
+    <p:bg>
+      <p:bgPr>
+        <a:solidFill>
+          <a:srgbClr val="FFFFFF"/>
+        </a:solidFill>
+      </p:bgPr>
+    </p:bg>
+    <p:spTree>
+      <p:nvGrpSpPr>
+        <p:cNvPr id="1" name=""/>
+        <p:cNvGrpSpPr/>
+        <p:nvPr/>
+      </p:nvGrpSpPr>
+      <p:grpSpPr>
+        <a:xfrm>
+          <a:off x="0" y="0"/>
+          <a:ext cx="0" cy="0"/>
+          <a:chOff x="0" y="0"/>
+          <a:chExt cx="0" cy="0"/>
+        </a:xfrm>
+      </p:grpSpPr>
+      <p:sp>
+        <p:nvSpPr>
+          <p:cNvPr id="2" name="Text 0"/>
+          <p:cNvSpPr/>
+          <p:nvPr/>
+        </p:nvSpPr>
+        <p:spPr>
+          <a:xfrm>
+            <a:off x="822960" y="640080"/>
+            <a:ext cx="5486400" cy="274320"/>
+          </a:xfrm>
+          <a:prstGeom prst="rect">
+            <a:avLst/>
+          </a:prstGeom>
+          <a:noFill/>
+          <a:ln/>
+        </p:spPr>
+        <p:txBody>
+          <a:bodyPr wrap="square" lIns="0" tIns="0" rIns="0" bIns="0" rtlCol="0" anchor="ctr"/>
+          <a:lstStyle/>
+          <a:p>
+            <a:pPr indent="0" marL="0">
+              <a:buNone/>
+            </a:pPr>
+            <a:r>
+              <a:rPr lang="en-US" sz="1100" b="1" spc="300" kern="0" dirty="0">
+                <a:solidFill>
+                  <a:srgbClr val="6C5CE7"/>
+                </a:solidFill>
+                <a:latin typeface="Malgun Gothic" pitchFamily="34" charset="0"/>
+                <a:ea typeface="Malgun Gothic" pitchFamily="34" charset="-122"/>
+                <a:cs typeface="Malgun Gothic" pitchFamily="34" charset="-120"/>
+              </a:rPr>
+              <a:t>안심</a:t>
+            </a:r>
+            <a:endParaRPr lang="en-US" sz="1100" dirty="0"/>
+          </a:p>
+        </p:txBody>
+      </p:sp>
+      <p:sp>
+        <p:nvSpPr>
+          <p:cNvPr id="3" name="Text 1"/>
+          <p:cNvSpPr/>
+          <p:nvPr/>
+        </p:nvSpPr>
+        <p:spPr>
+          <a:xfrm>
+            <a:off x="822960" y="914400"/>
+            <a:ext cx="8229600" cy="731520"/>
+          </a:xfrm>
+          <a:prstGeom prst="rect">
+            <a:avLst/>
+          </a:prstGeom>
+          <a:noFill/>
+          <a:ln/>
+        </p:spPr>
+        <p:txBody>
+          <a:bodyPr wrap="square" lIns="0" tIns="0" rIns="0" bIns="0" rtlCol="0" anchor="ctr"/>
+          <a:lstStyle/>
+          <a:p>
+            <a:pPr indent="0" marL="0">
+              <a:buNone/>
+            </a:pPr>
+            <a:r>
+              <a:rPr lang="en-US" sz="3100" b="1" dirty="0">
+                <a:solidFill>
+                  <a:srgbClr val="26263A"/>
+                </a:solidFill>
+                <a:latin typeface="Malgun Gothic" pitchFamily="34" charset="0"/>
+                <a:ea typeface="Malgun Gothic" pitchFamily="34" charset="-122"/>
+                <a:cs typeface="Malgun Gothic" pitchFamily="34" charset="-120"/>
+              </a:rPr>
+              <a:t>전부 내 컴퓨터에, 백업은 파일 하나</a:t>
+            </a:r>
+            <a:endParaRPr lang="en-US" sz="3100" dirty="0"/>
+          </a:p>
+        </p:txBody>
+      </p:sp>
+      <p:sp>
+        <p:nvSpPr>
+          <p:cNvPr id="4" name="Shape 2"/>
+          <p:cNvSpPr/>
+          <p:nvPr/>
+        </p:nvSpPr>
+        <p:spPr>
+          <a:xfrm>
+            <a:off x="822960" y="1965960"/>
+            <a:ext cx="5120640" cy="1051560"/>
+          </a:xfrm>
+          <a:prstGeom prst="roundRect">
+            <a:avLst>
+              <a:gd name="adj" fmla="val 8696"/>
+            </a:avLst>
+          </a:prstGeom>
+          <a:solidFill>
+            <a:srgbClr val="F7F6FE"/>
+          </a:solidFill>
+          <a:ln/>
+        </p:spPr>
+      </p:sp>
+      <p:sp>
+        <p:nvSpPr>
+          <p:cNvPr id="5" name="Shape 3"/>
+          <p:cNvSpPr/>
+          <p:nvPr/>
+        </p:nvSpPr>
+        <p:spPr>
+          <a:xfrm>
+            <a:off x="1051560" y="2203704"/>
+            <a:ext cx="566928" cy="566928"/>
+          </a:xfrm>
+          <a:prstGeom prst="ellipse">
+            <a:avLst/>
+          </a:prstGeom>
+          <a:solidFill>
+            <a:srgbClr val="6C5CE7"/>
+          </a:solidFill>
+          <a:ln/>
+        </p:spPr>
+      </p:sp>
+      <p:pic>
+        <p:nvPicPr>
+          <p:cNvPr id="6" name="Image 0" descr="preencoded.png">    </p:cNvPr>
+          <p:cNvPicPr>
+            <a:picLocks noChangeAspect="1"/>
+          </p:cNvPicPr>
+          <p:nvPr/>
+        </p:nvPicPr>
+        <p:blipFill>
+          <a:blip r:embed="rId1"/>
+          <a:stretch>
+            <a:fillRect/>
+          </a:stretch>
+        </p:blipFill>
+        <p:spPr>
+          <a:xfrm>
+            <a:off x="1198961" y="2351105"/>
+            <a:ext cx="272125" cy="272125"/>
+          </a:xfrm>
+          <a:prstGeom prst="rect">
+            <a:avLst/>
+          </a:prstGeom>
+        </p:spPr>
+      </p:pic>
+      <p:sp>
+        <p:nvSpPr>
+          <p:cNvPr id="7" name="Text 4"/>
+          <p:cNvSpPr/>
+          <p:nvPr/>
+        </p:nvSpPr>
+        <p:spPr>
+          <a:xfrm>
+            <a:off x="1828800" y="2148840"/>
+            <a:ext cx="3931920" cy="365760"/>
+          </a:xfrm>
+          <a:prstGeom prst="rect">
+            <a:avLst/>
+          </a:prstGeom>
+          <a:noFill/>
+          <a:ln/>
+        </p:spPr>
+        <p:txBody>
+          <a:bodyPr wrap="square" lIns="0" tIns="0" rIns="0" bIns="0" rtlCol="0" anchor="ctr"/>
+          <a:lstStyle/>
+          <a:p>
+            <a:pPr indent="0" marL="0">
+              <a:buNone/>
+            </a:pPr>
+            <a:r>
+              <a:rPr lang="en-US" sz="1600" b="1" dirty="0">
+                <a:solidFill>
+                  <a:srgbClr val="26263A"/>
+                </a:solidFill>
+                <a:latin typeface="Malgun Gothic" pitchFamily="34" charset="0"/>
+                <a:ea typeface="Malgun Gothic" pitchFamily="34" charset="-122"/>
+                <a:cs typeface="Malgun Gothic" pitchFamily="34" charset="-120"/>
+              </a:rPr>
+              <a:t>내 브라우저에만</a:t>
+            </a:r>
+            <a:endParaRPr lang="en-US" sz="1600" dirty="0"/>
+          </a:p>
+        </p:txBody>
+      </p:sp>
+      <p:sp>
+        <p:nvSpPr>
+          <p:cNvPr id="8" name="Text 5"/>
+          <p:cNvSpPr/>
+          <p:nvPr/>
+        </p:nvSpPr>
+        <p:spPr>
+          <a:xfrm>
+            <a:off x="1828800" y="2496312"/>
+            <a:ext cx="3977640" cy="457200"/>
+          </a:xfrm>
+          <a:prstGeom prst="rect">
+            <a:avLst/>
+          </a:prstGeom>
+          <a:noFill/>
+          <a:ln/>
+        </p:spPr>
+        <p:txBody>
+          <a:bodyPr wrap="square" lIns="0" tIns="0" rIns="0" bIns="0" rtlCol="0" anchor="ctr"/>
+          <a:lstStyle/>
+          <a:p>
+            <a:pPr indent="0" marL="0">
+              <a:buNone/>
+            </a:pPr>
+            <a:r>
+              <a:rPr lang="en-US" sz="1250" dirty="0">
+                <a:solidFill>
+                  <a:srgbClr val="6E6E82"/>
+                </a:solidFill>
+                <a:latin typeface="Malgun Gothic" pitchFamily="34" charset="0"/>
+                <a:ea typeface="Malgun Gothic" pitchFamily="34" charset="-122"/>
+                <a:cs typeface="Malgun Gothic" pitchFamily="34" charset="-120"/>
+              </a:rPr>
+              <a:t>계정도 서버도 없이 내 컴퓨터에 저장된다.</a:t>
+            </a:r>
+            <a:endParaRPr lang="en-US" sz="1250" dirty="0"/>
+          </a:p>
+        </p:txBody>
+      </p:sp>
+      <p:sp>
+        <p:nvSpPr>
+          <p:cNvPr id="9" name="Shape 6"/>
+          <p:cNvSpPr/>
+          <p:nvPr/>
+        </p:nvSpPr>
+        <p:spPr>
+          <a:xfrm>
+            <a:off x="822960" y="3200400"/>
+            <a:ext cx="5120640" cy="1051560"/>
+          </a:xfrm>
+          <a:prstGeom prst="roundRect">
+            <a:avLst>
+              <a:gd name="adj" fmla="val 8696"/>
+            </a:avLst>
+          </a:prstGeom>
+          <a:solidFill>
+            <a:srgbClr val="F7F6FE"/>
+          </a:solidFill>
+          <a:ln/>
+        </p:spPr>
+      </p:sp>
+      <p:sp>
+        <p:nvSpPr>
+          <p:cNvPr id="10" name="Shape 7"/>
+          <p:cNvSpPr/>
+          <p:nvPr/>
+        </p:nvSpPr>
+        <p:spPr>
+          <a:xfrm>
+            <a:off x="1051560" y="3438144"/>
+            <a:ext cx="566928" cy="566928"/>
+          </a:xfrm>
+          <a:prstGeom prst="ellipse">
+            <a:avLst/>
+          </a:prstGeom>
+          <a:solidFill>
+            <a:srgbClr val="6C5CE7"/>
+          </a:solidFill>
+          <a:ln/>
+        </p:spPr>
+      </p:sp>
+      <p:pic>
+        <p:nvPicPr>
+          <p:cNvPr id="11" name="Image 1" descr="preencoded.png">    </p:cNvPr>
+          <p:cNvPicPr>
+            <a:picLocks noChangeAspect="1"/>
+          </p:cNvPicPr>
+          <p:nvPr/>
+        </p:nvPicPr>
+        <p:blipFill>
+          <a:blip r:embed="rId2"/>
+          <a:stretch>
+            <a:fillRect/>
+          </a:stretch>
+        </p:blipFill>
+        <p:spPr>
+          <a:xfrm>
+            <a:off x="1198961" y="3585545"/>
+            <a:ext cx="272125" cy="272125"/>
+          </a:xfrm>
+          <a:prstGeom prst="rect">
+            <a:avLst/>
+          </a:prstGeom>
+        </p:spPr>
+      </p:pic>
+      <p:sp>
+        <p:nvSpPr>
+          <p:cNvPr id="12" name="Text 8"/>
+          <p:cNvSpPr/>
+          <p:nvPr/>
+        </p:nvSpPr>
+        <p:spPr>
+          <a:xfrm>
+            <a:off x="1828800" y="3383280"/>
+            <a:ext cx="3931920" cy="365760"/>
+          </a:xfrm>
+          <a:prstGeom prst="rect">
+            <a:avLst/>
+          </a:prstGeom>
+          <a:noFill/>
+          <a:ln/>
+        </p:spPr>
+        <p:txBody>
+          <a:bodyPr wrap="square" lIns="0" tIns="0" rIns="0" bIns="0" rtlCol="0" anchor="ctr"/>
+          <a:lstStyle/>
+          <a:p>
+            <a:pPr indent="0" marL="0">
+              <a:buNone/>
+            </a:pPr>
+            <a:r>
+              <a:rPr lang="en-US" sz="1600" b="1" dirty="0">
+                <a:solidFill>
+                  <a:srgbClr val="26263A"/>
+                </a:solidFill>
+                <a:latin typeface="Malgun Gothic" pitchFamily="34" charset="0"/>
+                <a:ea typeface="Malgun Gothic" pitchFamily="34" charset="-122"/>
+                <a:cs typeface="Malgun Gothic" pitchFamily="34" charset="-120"/>
+              </a:rPr>
+              <a:t>통째로 백업·복구</a:t>
+            </a:r>
+            <a:endParaRPr lang="en-US" sz="1600" dirty="0"/>
+          </a:p>
+        </p:txBody>
+      </p:sp>
+      <p:sp>
+        <p:nvSpPr>
+          <p:cNvPr id="13" name="Text 9"/>
+          <p:cNvSpPr/>
+          <p:nvPr/>
+        </p:nvSpPr>
+        <p:spPr>
+          <a:xfrm>
+            <a:off x="1828800" y="3730752"/>
+            <a:ext cx="3977640" cy="457200"/>
+          </a:xfrm>
+          <a:prstGeom prst="rect">
+            <a:avLst/>
+          </a:prstGeom>
+          <a:noFill/>
+          <a:ln/>
+        </p:spPr>
+        <p:txBody>
+          <a:bodyPr wrap="square" lIns="0" tIns="0" rIns="0" bIns="0" rtlCol="0" anchor="ctr"/>
+          <a:lstStyle/>
+          <a:p>
+            <a:pPr indent="0" marL="0">
+              <a:buNone/>
+            </a:pPr>
+            <a:r>
+              <a:rPr lang="en-US" sz="1250" dirty="0">
+                <a:solidFill>
+                  <a:srgbClr val="6E6E82"/>
+                </a:solidFill>
+                <a:latin typeface="Malgun Gothic" pitchFamily="34" charset="0"/>
+                <a:ea typeface="Malgun Gothic" pitchFamily="34" charset="-122"/>
+                <a:cs typeface="Malgun Gothic" pitchFamily="34" charset="-120"/>
+              </a:rPr>
+              <a:t>파일 하나로 옮기고, 필요하면 되돌린다.</a:t>
+            </a:r>
+            <a:endParaRPr lang="en-US" sz="1250" dirty="0"/>
+          </a:p>
+        </p:txBody>
+      </p:sp>
+      <p:sp>
+        <p:nvSpPr>
+          <p:cNvPr id="14" name="Shape 10"/>
+          <p:cNvSpPr/>
+          <p:nvPr/>
+        </p:nvSpPr>
+        <p:spPr>
+          <a:xfrm>
+            <a:off x="822960" y="4434840"/>
+            <a:ext cx="5120640" cy="1051560"/>
+          </a:xfrm>
+          <a:prstGeom prst="roundRect">
+            <a:avLst>
+              <a:gd name="adj" fmla="val 8696"/>
+            </a:avLst>
+          </a:prstGeom>
+          <a:solidFill>
+            <a:srgbClr val="F7F6FE"/>
+          </a:solidFill>
+          <a:ln/>
+        </p:spPr>
+      </p:sp>
+      <p:sp>
+        <p:nvSpPr>
+          <p:cNvPr id="15" name="Shape 11"/>
+          <p:cNvSpPr/>
+          <p:nvPr/>
+        </p:nvSpPr>
+        <p:spPr>
+          <a:xfrm>
+            <a:off x="1051560" y="4672584"/>
+            <a:ext cx="566928" cy="566928"/>
+          </a:xfrm>
+          <a:prstGeom prst="ellipse">
+            <a:avLst/>
+          </a:prstGeom>
+          <a:solidFill>
+            <a:srgbClr val="6C5CE7"/>
+          </a:solidFill>
+          <a:ln/>
+        </p:spPr>
+      </p:sp>
+      <p:pic>
+        <p:nvPicPr>
+          <p:cNvPr id="16" name="Image 2" descr="preencoded.png">    </p:cNvPr>
+          <p:cNvPicPr>
+            <a:picLocks noChangeAspect="1"/>
+          </p:cNvPicPr>
+          <p:nvPr/>
+        </p:nvPicPr>
+        <p:blipFill>
+          <a:blip r:embed="rId3"/>
+          <a:stretch>
+            <a:fillRect/>
+          </a:stretch>
+        </p:blipFill>
+        <p:spPr>
+          <a:xfrm>
+            <a:off x="1198961" y="4819985"/>
+            <a:ext cx="272125" cy="272125"/>
+          </a:xfrm>
+          <a:prstGeom prst="rect">
+            <a:avLst/>
+          </a:prstGeom>
+        </p:spPr>
+      </p:pic>
+      <p:sp>
+        <p:nvSpPr>
+          <p:cNvPr id="17" name="Text 12"/>
+          <p:cNvSpPr/>
+          <p:nvPr/>
+        </p:nvSpPr>
+        <p:spPr>
+          <a:xfrm>
+            <a:off x="1828800" y="4617720"/>
+            <a:ext cx="3931920" cy="365760"/>
+          </a:xfrm>
+          <a:prstGeom prst="rect">
+            <a:avLst/>
+          </a:prstGeom>
+          <a:noFill/>
+          <a:ln/>
+        </p:spPr>
+        <p:txBody>
+          <a:bodyPr wrap="square" lIns="0" tIns="0" rIns="0" bIns="0" rtlCol="0" anchor="ctr"/>
+          <a:lstStyle/>
+          <a:p>
+            <a:pPr indent="0" marL="0">
+              <a:buNone/>
+            </a:pPr>
+            <a:r>
+              <a:rPr lang="en-US" sz="1600" b="1" dirty="0">
+                <a:solidFill>
+                  <a:srgbClr val="26263A"/>
+                </a:solidFill>
+                <a:latin typeface="Malgun Gothic" pitchFamily="34" charset="0"/>
+                <a:ea typeface="Malgun Gothic" pitchFamily="34" charset="-122"/>
+                <a:cs typeface="Malgun Gothic" pitchFamily="34" charset="-120"/>
+              </a:rPr>
+              <a:t>쌓인 현황을 한눈에</a:t>
+            </a:r>
+            <a:endParaRPr lang="en-US" sz="1600" dirty="0"/>
+          </a:p>
+        </p:txBody>
+      </p:sp>
+      <p:sp>
+        <p:nvSpPr>
+          <p:cNvPr id="18" name="Text 13"/>
+          <p:cNvSpPr/>
+          <p:nvPr/>
+        </p:nvSpPr>
+        <p:spPr>
+          <a:xfrm>
+            <a:off x="1828800" y="4965192"/>
+            <a:ext cx="3977640" cy="457200"/>
+          </a:xfrm>
+          <a:prstGeom prst="rect">
+            <a:avLst/>
+          </a:prstGeom>
+          <a:noFill/>
+          <a:ln/>
+        </p:spPr>
+        <p:txBody>
+          <a:bodyPr wrap="square" lIns="0" tIns="0" rIns="0" bIns="0" rtlCol="0" anchor="ctr"/>
+          <a:lstStyle/>
+          <a:p>
+            <a:pPr indent="0" marL="0">
+              <a:buNone/>
+            </a:pPr>
+            <a:r>
+              <a:rPr lang="en-US" sz="1250" dirty="0">
+                <a:solidFill>
+                  <a:srgbClr val="6E6E82"/>
+                </a:solidFill>
+                <a:latin typeface="Malgun Gothic" pitchFamily="34" charset="0"/>
+                <a:ea typeface="Malgun Gothic" pitchFamily="34" charset="-122"/>
+                <a:cs typeface="Malgun Gothic" pitchFamily="34" charset="-120"/>
+              </a:rPr>
+              <a:t>일정·메모·사용량을 통계로 확인한다.</a:t>
+            </a:r>
+            <a:endParaRPr lang="en-US" sz="1250" dirty="0"/>
+          </a:p>
+        </p:txBody>
+      </p:sp>
+      <p:sp>
+        <p:nvSpPr>
+          <p:cNvPr id="19" name="Shape 14"/>
+          <p:cNvSpPr/>
+          <p:nvPr/>
+        </p:nvSpPr>
+        <p:spPr>
+          <a:xfrm>
+            <a:off x="6437376" y="1773936"/>
+            <a:ext cx="6100877" cy="4270248"/>
+          </a:xfrm>
+          <a:prstGeom prst="roundRect">
+            <a:avLst>
+              <a:gd name="adj" fmla="val 1927"/>
+            </a:avLst>
+          </a:prstGeom>
+          <a:solidFill>
+            <a:srgbClr val="FFFFFF"/>
+          </a:solidFill>
+          <a:ln w="12700">
+            <a:solidFill>
+              <a:srgbClr val="E6E4F5"/>
+            </a:solidFill>
+            <a:prstDash val="solid"/>
+          </a:ln>
+          <a:effectLst>
+            <a:outerShdw sx="100000" sy="100000" kx="0" ky="0" algn="bl" rotWithShape="0" blurRad="152400" dist="50800" dir="5400000">
+              <a:srgbClr val="16172A">
+                <a:alpha val="10000"/>
+              </a:srgbClr>
+            </a:outerShdw>
+          </a:effectLst>
+        </p:spPr>
+      </p:sp>
+      <p:pic>
+        <p:nvPicPr>
+          <p:cNvPr id="20" name="Image 3" descr="C:\Users\sohnj\Project\260627 AI Planner 클로드\docs\images\stats.png">    </p:cNvPr>
+          <p:cNvPicPr>
+            <a:picLocks noChangeAspect="1"/>
+          </p:cNvPicPr>
+          <p:nvPr/>
+        </p:nvPicPr>
+        <p:blipFill>
+          <a:blip r:embed="rId4"/>
+          <a:stretch>
+            <a:fillRect/>
+          </a:stretch>
+        </p:blipFill>
+        <p:spPr>
+          <a:xfrm>
+            <a:off x="6492240" y="1828800"/>
+            <a:ext cx="5991149" cy="4160520"/>
+          </a:xfrm>
+          <a:prstGeom prst="rect">
+            <a:avLst/>
+          </a:prstGeom>
+        </p:spPr>
+      </p:pic>
+    </p:spTree>
+  </p:cSld>
+  <p:clrMapOvr>
+    <a:masterClrMapping/>
+  </p:clrMapOvr>
+</p:sld>
+</file>
+
+<file path=ppt/slides/slide8.xml><?xml version="1.0" encoding="utf-8"?>
+<p:sld xmlns:a="http://schemas.openxmlformats.org/drawingml/2006/main" xmlns:r="http://schemas.openxmlformats.org/officeDocument/2006/relationships" xmlns:p="http://schemas.openxmlformats.org/presentationml/2006/main">
+  <p:cSld name="Slide 8">
     <p:bg>
       <p:bgPr>
         <a:solidFill>
@@ -4820,1698 +5312,6 @@
       </p:grpSpPr>
       <p:sp>
         <p:nvSpPr>
-          <p:cNvPr id="2" name="Text 0"/>
-          <p:cNvSpPr/>
-          <p:nvPr/>
-        </p:nvSpPr>
-        <p:spPr>
-          <a:xfrm>
-            <a:off x="822960" y="640080"/>
-            <a:ext cx="5486400" cy="274320"/>
-          </a:xfrm>
-          <a:prstGeom prst="rect">
-            <a:avLst/>
-          </a:prstGeom>
-          <a:noFill/>
-          <a:ln/>
-        </p:spPr>
-        <p:txBody>
-          <a:bodyPr wrap="square" lIns="0" tIns="0" rIns="0" bIns="0" rtlCol="0" anchor="ctr"/>
-          <a:lstStyle/>
-          <a:p>
-            <a:pPr indent="0" marL="0">
-              <a:buNone/>
-            </a:pPr>
-            <a:r>
-              <a:rPr lang="en-US" sz="1100" b="1" spc="300" kern="0" dirty="0">
-                <a:solidFill>
-                  <a:srgbClr val="B7ADF7"/>
-                </a:solidFill>
-                <a:latin typeface="Malgun Gothic" pitchFamily="34" charset="0"/>
-                <a:ea typeface="Malgun Gothic" pitchFamily="34" charset="-122"/>
-                <a:cs typeface="Malgun Gothic" pitchFamily="34" charset="-120"/>
-              </a:rPr>
-              <a:t>HOW IT WORKS</a:t>
-            </a:r>
-            <a:endParaRPr lang="en-US" sz="1100" dirty="0"/>
-          </a:p>
-        </p:txBody>
-      </p:sp>
-      <p:sp>
-        <p:nvSpPr>
-          <p:cNvPr id="3" name="Text 1"/>
-          <p:cNvSpPr/>
-          <p:nvPr/>
-        </p:nvSpPr>
-        <p:spPr>
-          <a:xfrm>
-            <a:off x="822960" y="914400"/>
-            <a:ext cx="8229600" cy="731520"/>
-          </a:xfrm>
-          <a:prstGeom prst="rect">
-            <a:avLst/>
-          </a:prstGeom>
-          <a:noFill/>
-          <a:ln/>
-        </p:spPr>
-        <p:txBody>
-          <a:bodyPr wrap="square" lIns="0" tIns="0" rIns="0" bIns="0" rtlCol="0" anchor="ctr"/>
-          <a:lstStyle/>
-          <a:p>
-            <a:pPr indent="0" marL="0">
-              <a:buNone/>
-            </a:pPr>
-            <a:r>
-              <a:rPr lang="en-US" sz="3200" b="1" dirty="0">
-                <a:solidFill>
-                  <a:srgbClr val="FFFFFF"/>
-                </a:solidFill>
-                <a:latin typeface="Malgun Gothic" pitchFamily="34" charset="0"/>
-                <a:ea typeface="Malgun Gothic" pitchFamily="34" charset="-122"/>
-                <a:cs typeface="Malgun Gothic" pitchFamily="34" charset="-120"/>
-              </a:rPr>
-              <a:t>AI는 이렇게 움직인다</a:t>
-            </a:r>
-            <a:endParaRPr lang="en-US" sz="3200" dirty="0"/>
-          </a:p>
-        </p:txBody>
-      </p:sp>
-      <p:sp>
-        <p:nvSpPr>
-          <p:cNvPr id="4" name="Text 2"/>
-          <p:cNvSpPr/>
-          <p:nvPr/>
-        </p:nvSpPr>
-        <p:spPr>
-          <a:xfrm>
-            <a:off x="822960" y="1627632"/>
-            <a:ext cx="10058400" cy="365760"/>
-          </a:xfrm>
-          <a:prstGeom prst="rect">
-            <a:avLst/>
-          </a:prstGeom>
-          <a:noFill/>
-          <a:ln/>
-        </p:spPr>
-        <p:txBody>
-          <a:bodyPr wrap="square" lIns="0" tIns="0" rIns="0" bIns="0" rtlCol="0" anchor="ctr"/>
-          <a:lstStyle/>
-          <a:p>
-            <a:pPr indent="0" marL="0">
-              <a:buNone/>
-            </a:pPr>
-            <a:r>
-              <a:rPr lang="en-US" sz="1400" dirty="0">
-                <a:solidFill>
-                  <a:srgbClr val="C9C9E8"/>
-                </a:solidFill>
-                <a:latin typeface="Malgun Gothic" pitchFamily="34" charset="0"/>
-                <a:ea typeface="Malgun Gothic" pitchFamily="34" charset="-122"/>
-                <a:cs typeface="Malgun Gothic" pitchFamily="34" charset="-120"/>
-              </a:rPr>
-              <a:t>네이티브 function calling 없이, 프롬프트로 도구를 지시하고 결과를 다시 물어보는 루프.</a:t>
-            </a:r>
-            <a:endParaRPr lang="en-US" sz="1400" dirty="0"/>
-          </a:p>
-        </p:txBody>
-      </p:sp>
-      <p:sp>
-        <p:nvSpPr>
-          <p:cNvPr id="5" name="Shape 3"/>
-          <p:cNvSpPr/>
-          <p:nvPr/>
-        </p:nvSpPr>
-        <p:spPr>
-          <a:xfrm>
-            <a:off x="822960" y="2286000"/>
-            <a:ext cx="2615184" cy="1828800"/>
-          </a:xfrm>
-          <a:prstGeom prst="roundRect">
-            <a:avLst>
-              <a:gd name="adj" fmla="val 5000"/>
-            </a:avLst>
-          </a:prstGeom>
-          <a:solidFill>
-            <a:srgbClr val="22233D"/>
-          </a:solidFill>
-          <a:ln/>
-        </p:spPr>
-      </p:sp>
-      <p:sp>
-        <p:nvSpPr>
-          <p:cNvPr id="6" name="Shape 4"/>
-          <p:cNvSpPr/>
-          <p:nvPr/>
-        </p:nvSpPr>
-        <p:spPr>
-          <a:xfrm>
-            <a:off x="1078992" y="2542032"/>
-            <a:ext cx="548640" cy="548640"/>
-          </a:xfrm>
-          <a:prstGeom prst="ellipse">
-            <a:avLst/>
-          </a:prstGeom>
-          <a:solidFill>
-            <a:srgbClr val="6C5CE7"/>
-          </a:solidFill>
-          <a:ln/>
-        </p:spPr>
-      </p:sp>
-      <p:sp>
-        <p:nvSpPr>
-          <p:cNvPr id="7" name="Text 5"/>
-          <p:cNvSpPr/>
-          <p:nvPr/>
-        </p:nvSpPr>
-        <p:spPr>
-          <a:xfrm>
-            <a:off x="1078992" y="2542032"/>
-            <a:ext cx="548640" cy="548640"/>
-          </a:xfrm>
-          <a:prstGeom prst="rect">
-            <a:avLst/>
-          </a:prstGeom>
-          <a:noFill/>
-          <a:ln/>
-        </p:spPr>
-        <p:txBody>
-          <a:bodyPr wrap="square" lIns="0" tIns="0" rIns="0" bIns="0" rtlCol="0" anchor="ctr"/>
-          <a:lstStyle/>
-          <a:p>
-            <a:pPr algn="ctr" indent="0" marL="0">
-              <a:buNone/>
-            </a:pPr>
-            <a:r>
-              <a:rPr lang="en-US" sz="2200" b="1" dirty="0">
-                <a:solidFill>
-                  <a:srgbClr val="FFFFFF"/>
-                </a:solidFill>
-                <a:latin typeface="Malgun Gothic" pitchFamily="34" charset="0"/>
-                <a:ea typeface="Malgun Gothic" pitchFamily="34" charset="-122"/>
-                <a:cs typeface="Malgun Gothic" pitchFamily="34" charset="-120"/>
-              </a:rPr>
-              <a:t>1</a:t>
-            </a:r>
-            <a:endParaRPr lang="en-US" sz="2200" dirty="0"/>
-          </a:p>
-        </p:txBody>
-      </p:sp>
-      <p:sp>
-        <p:nvSpPr>
-          <p:cNvPr id="8" name="Text 6"/>
-          <p:cNvSpPr/>
-          <p:nvPr/>
-        </p:nvSpPr>
-        <p:spPr>
-          <a:xfrm>
-            <a:off x="1078992" y="3246120"/>
-            <a:ext cx="2157984" cy="365760"/>
-          </a:xfrm>
-          <a:prstGeom prst="rect">
-            <a:avLst/>
-          </a:prstGeom>
-          <a:noFill/>
-          <a:ln/>
-        </p:spPr>
-        <p:txBody>
-          <a:bodyPr wrap="square" lIns="0" tIns="0" rIns="0" bIns="0" rtlCol="0" anchor="ctr"/>
-          <a:lstStyle/>
-          <a:p>
-            <a:pPr indent="0" marL="0">
-              <a:buNone/>
-            </a:pPr>
-            <a:r>
-              <a:rPr lang="en-US" sz="1800" b="1" dirty="0">
-                <a:solidFill>
-                  <a:srgbClr val="FFFFFF"/>
-                </a:solidFill>
-                <a:latin typeface="Malgun Gothic" pitchFamily="34" charset="0"/>
-                <a:ea typeface="Malgun Gothic" pitchFamily="34" charset="-122"/>
-                <a:cs typeface="Malgun Gothic" pitchFamily="34" charset="-120"/>
-              </a:rPr>
-              <a:t>지시</a:t>
-            </a:r>
-            <a:endParaRPr lang="en-US" sz="1800" dirty="0"/>
-          </a:p>
-        </p:txBody>
-      </p:sp>
-      <p:sp>
-        <p:nvSpPr>
-          <p:cNvPr id="9" name="Text 7"/>
-          <p:cNvSpPr/>
-          <p:nvPr/>
-        </p:nvSpPr>
-        <p:spPr>
-          <a:xfrm>
-            <a:off x="1078992" y="3611880"/>
-            <a:ext cx="2157984" cy="457200"/>
-          </a:xfrm>
-          <a:prstGeom prst="rect">
-            <a:avLst/>
-          </a:prstGeom>
-          <a:noFill/>
-          <a:ln/>
-        </p:spPr>
-        <p:txBody>
-          <a:bodyPr wrap="square" lIns="0" tIns="0" rIns="0" bIns="0" rtlCol="0" anchor="ctr"/>
-          <a:lstStyle/>
-          <a:p>
-            <a:pPr indent="0" marL="0">
-              <a:lnSpc>
-                <a:spcPct val="115000"/>
-              </a:lnSpc>
-              <a:buNone/>
-            </a:pPr>
-            <a:r>
-              <a:rPr lang="en-US" sz="1200" dirty="0">
-                <a:solidFill>
-                  <a:srgbClr val="C9C9E8"/>
-                </a:solidFill>
-                <a:latin typeface="Malgun Gothic" pitchFamily="34" charset="0"/>
-                <a:ea typeface="Malgun Gothic" pitchFamily="34" charset="-122"/>
-                <a:cs typeface="Malgun Gothic" pitchFamily="34" charset="-120"/>
-              </a:rPr>
-              <a:t>프롬프트로 JSON 스키마와 도구 목록을 준다.</a:t>
-            </a:r>
-            <a:endParaRPr lang="en-US" sz="1200" dirty="0"/>
-          </a:p>
-        </p:txBody>
-      </p:sp>
-      <p:sp>
-        <p:nvSpPr>
-          <p:cNvPr id="10" name="Shape 8"/>
-          <p:cNvSpPr/>
-          <p:nvPr/>
-        </p:nvSpPr>
-        <p:spPr>
-          <a:xfrm>
-            <a:off x="3657600" y="2286000"/>
-            <a:ext cx="2615184" cy="1828800"/>
-          </a:xfrm>
-          <a:prstGeom prst="roundRect">
-            <a:avLst>
-              <a:gd name="adj" fmla="val 5000"/>
-            </a:avLst>
-          </a:prstGeom>
-          <a:solidFill>
-            <a:srgbClr val="22233D"/>
-          </a:solidFill>
-          <a:ln/>
-        </p:spPr>
-      </p:sp>
-      <p:sp>
-        <p:nvSpPr>
-          <p:cNvPr id="11" name="Shape 9"/>
-          <p:cNvSpPr/>
-          <p:nvPr/>
-        </p:nvSpPr>
-        <p:spPr>
-          <a:xfrm>
-            <a:off x="3913632" y="2542032"/>
-            <a:ext cx="548640" cy="548640"/>
-          </a:xfrm>
-          <a:prstGeom prst="ellipse">
-            <a:avLst/>
-          </a:prstGeom>
-          <a:solidFill>
-            <a:srgbClr val="6C5CE7"/>
-          </a:solidFill>
-          <a:ln/>
-        </p:spPr>
-      </p:sp>
-      <p:sp>
-        <p:nvSpPr>
-          <p:cNvPr id="12" name="Text 10"/>
-          <p:cNvSpPr/>
-          <p:nvPr/>
-        </p:nvSpPr>
-        <p:spPr>
-          <a:xfrm>
-            <a:off x="3913632" y="2542032"/>
-            <a:ext cx="548640" cy="548640"/>
-          </a:xfrm>
-          <a:prstGeom prst="rect">
-            <a:avLst/>
-          </a:prstGeom>
-          <a:noFill/>
-          <a:ln/>
-        </p:spPr>
-        <p:txBody>
-          <a:bodyPr wrap="square" lIns="0" tIns="0" rIns="0" bIns="0" rtlCol="0" anchor="ctr"/>
-          <a:lstStyle/>
-          <a:p>
-            <a:pPr algn="ctr" indent="0" marL="0">
-              <a:buNone/>
-            </a:pPr>
-            <a:r>
-              <a:rPr lang="en-US" sz="2200" b="1" dirty="0">
-                <a:solidFill>
-                  <a:srgbClr val="FFFFFF"/>
-                </a:solidFill>
-                <a:latin typeface="Malgun Gothic" pitchFamily="34" charset="0"/>
-                <a:ea typeface="Malgun Gothic" pitchFamily="34" charset="-122"/>
-                <a:cs typeface="Malgun Gothic" pitchFamily="34" charset="-120"/>
-              </a:rPr>
-              <a:t>2</a:t>
-            </a:r>
-            <a:endParaRPr lang="en-US" sz="2200" dirty="0"/>
-          </a:p>
-        </p:txBody>
-      </p:sp>
-      <p:sp>
-        <p:nvSpPr>
-          <p:cNvPr id="13" name="Text 11"/>
-          <p:cNvSpPr/>
-          <p:nvPr/>
-        </p:nvSpPr>
-        <p:spPr>
-          <a:xfrm>
-            <a:off x="3913632" y="3246120"/>
-            <a:ext cx="2157984" cy="365760"/>
-          </a:xfrm>
-          <a:prstGeom prst="rect">
-            <a:avLst/>
-          </a:prstGeom>
-          <a:noFill/>
-          <a:ln/>
-        </p:spPr>
-        <p:txBody>
-          <a:bodyPr wrap="square" lIns="0" tIns="0" rIns="0" bIns="0" rtlCol="0" anchor="ctr"/>
-          <a:lstStyle/>
-          <a:p>
-            <a:pPr indent="0" marL="0">
-              <a:buNone/>
-            </a:pPr>
-            <a:r>
-              <a:rPr lang="en-US" sz="1800" b="1" dirty="0">
-                <a:solidFill>
-                  <a:srgbClr val="FFFFFF"/>
-                </a:solidFill>
-                <a:latin typeface="Malgun Gothic" pitchFamily="34" charset="0"/>
-                <a:ea typeface="Malgun Gothic" pitchFamily="34" charset="-122"/>
-                <a:cs typeface="Malgun Gothic" pitchFamily="34" charset="-120"/>
-              </a:rPr>
-              <a:t>호출</a:t>
-            </a:r>
-            <a:endParaRPr lang="en-US" sz="1800" dirty="0"/>
-          </a:p>
-        </p:txBody>
-      </p:sp>
-      <p:sp>
-        <p:nvSpPr>
-          <p:cNvPr id="14" name="Text 12"/>
-          <p:cNvSpPr/>
-          <p:nvPr/>
-        </p:nvSpPr>
-        <p:spPr>
-          <a:xfrm>
-            <a:off x="3913632" y="3611880"/>
-            <a:ext cx="2157984" cy="457200"/>
-          </a:xfrm>
-          <a:prstGeom prst="rect">
-            <a:avLst/>
-          </a:prstGeom>
-          <a:noFill/>
-          <a:ln/>
-        </p:spPr>
-        <p:txBody>
-          <a:bodyPr wrap="square" lIns="0" tIns="0" rIns="0" bIns="0" rtlCol="0" anchor="ctr"/>
-          <a:lstStyle/>
-          <a:p>
-            <a:pPr indent="0" marL="0">
-              <a:lnSpc>
-                <a:spcPct val="115000"/>
-              </a:lnSpc>
-              <a:buNone/>
-            </a:pPr>
-            <a:r>
-              <a:rPr lang="en-US" sz="1200" dirty="0">
-                <a:solidFill>
-                  <a:srgbClr val="C9C9E8"/>
-                </a:solidFill>
-                <a:latin typeface="Malgun Gothic" pitchFamily="34" charset="0"/>
-                <a:ea typeface="Malgun Gothic" pitchFamily="34" charset="-122"/>
-                <a:cs typeface="Malgun Gothic" pitchFamily="34" charset="-120"/>
-              </a:rPr>
-              <a:t>모델이 필요한 도구 호출을 JSON으로 반환한다.</a:t>
-            </a:r>
-            <a:endParaRPr lang="en-US" sz="1200" dirty="0"/>
-          </a:p>
-        </p:txBody>
-      </p:sp>
-      <p:sp>
-        <p:nvSpPr>
-          <p:cNvPr id="15" name="Shape 13"/>
-          <p:cNvSpPr/>
-          <p:nvPr/>
-        </p:nvSpPr>
-        <p:spPr>
-          <a:xfrm>
-            <a:off x="6492240" y="2286000"/>
-            <a:ext cx="2615184" cy="1828800"/>
-          </a:xfrm>
-          <a:prstGeom prst="roundRect">
-            <a:avLst>
-              <a:gd name="adj" fmla="val 5000"/>
-            </a:avLst>
-          </a:prstGeom>
-          <a:solidFill>
-            <a:srgbClr val="22233D"/>
-          </a:solidFill>
-          <a:ln/>
-        </p:spPr>
-      </p:sp>
-      <p:sp>
-        <p:nvSpPr>
-          <p:cNvPr id="16" name="Shape 14"/>
-          <p:cNvSpPr/>
-          <p:nvPr/>
-        </p:nvSpPr>
-        <p:spPr>
-          <a:xfrm>
-            <a:off x="6748272" y="2542032"/>
-            <a:ext cx="548640" cy="548640"/>
-          </a:xfrm>
-          <a:prstGeom prst="ellipse">
-            <a:avLst/>
-          </a:prstGeom>
-          <a:solidFill>
-            <a:srgbClr val="6C5CE7"/>
-          </a:solidFill>
-          <a:ln/>
-        </p:spPr>
-      </p:sp>
-      <p:sp>
-        <p:nvSpPr>
-          <p:cNvPr id="17" name="Text 15"/>
-          <p:cNvSpPr/>
-          <p:nvPr/>
-        </p:nvSpPr>
-        <p:spPr>
-          <a:xfrm>
-            <a:off x="6748272" y="2542032"/>
-            <a:ext cx="548640" cy="548640"/>
-          </a:xfrm>
-          <a:prstGeom prst="rect">
-            <a:avLst/>
-          </a:prstGeom>
-          <a:noFill/>
-          <a:ln/>
-        </p:spPr>
-        <p:txBody>
-          <a:bodyPr wrap="square" lIns="0" tIns="0" rIns="0" bIns="0" rtlCol="0" anchor="ctr"/>
-          <a:lstStyle/>
-          <a:p>
-            <a:pPr algn="ctr" indent="0" marL="0">
-              <a:buNone/>
-            </a:pPr>
-            <a:r>
-              <a:rPr lang="en-US" sz="2200" b="1" dirty="0">
-                <a:solidFill>
-                  <a:srgbClr val="FFFFFF"/>
-                </a:solidFill>
-                <a:latin typeface="Malgun Gothic" pitchFamily="34" charset="0"/>
-                <a:ea typeface="Malgun Gothic" pitchFamily="34" charset="-122"/>
-                <a:cs typeface="Malgun Gothic" pitchFamily="34" charset="-120"/>
-              </a:rPr>
-              <a:t>3</a:t>
-            </a:r>
-            <a:endParaRPr lang="en-US" sz="2200" dirty="0"/>
-          </a:p>
-        </p:txBody>
-      </p:sp>
-      <p:sp>
-        <p:nvSpPr>
-          <p:cNvPr id="18" name="Text 16"/>
-          <p:cNvSpPr/>
-          <p:nvPr/>
-        </p:nvSpPr>
-        <p:spPr>
-          <a:xfrm>
-            <a:off x="6748272" y="3246120"/>
-            <a:ext cx="2157984" cy="365760"/>
-          </a:xfrm>
-          <a:prstGeom prst="rect">
-            <a:avLst/>
-          </a:prstGeom>
-          <a:noFill/>
-          <a:ln/>
-        </p:spPr>
-        <p:txBody>
-          <a:bodyPr wrap="square" lIns="0" tIns="0" rIns="0" bIns="0" rtlCol="0" anchor="ctr"/>
-          <a:lstStyle/>
-          <a:p>
-            <a:pPr indent="0" marL="0">
-              <a:buNone/>
-            </a:pPr>
-            <a:r>
-              <a:rPr lang="en-US" sz="1800" b="1" dirty="0">
-                <a:solidFill>
-                  <a:srgbClr val="FFFFFF"/>
-                </a:solidFill>
-                <a:latin typeface="Malgun Gothic" pitchFamily="34" charset="0"/>
-                <a:ea typeface="Malgun Gothic" pitchFamily="34" charset="-122"/>
-                <a:cs typeface="Malgun Gothic" pitchFamily="34" charset="-120"/>
-              </a:rPr>
-              <a:t>실행</a:t>
-            </a:r>
-            <a:endParaRPr lang="en-US" sz="1800" dirty="0"/>
-          </a:p>
-        </p:txBody>
-      </p:sp>
-      <p:sp>
-        <p:nvSpPr>
-          <p:cNvPr id="19" name="Text 17"/>
-          <p:cNvSpPr/>
-          <p:nvPr/>
-        </p:nvSpPr>
-        <p:spPr>
-          <a:xfrm>
-            <a:off x="6748272" y="3611880"/>
-            <a:ext cx="2157984" cy="457200"/>
-          </a:xfrm>
-          <a:prstGeom prst="rect">
-            <a:avLst/>
-          </a:prstGeom>
-          <a:noFill/>
-          <a:ln/>
-        </p:spPr>
-        <p:txBody>
-          <a:bodyPr wrap="square" lIns="0" tIns="0" rIns="0" bIns="0" rtlCol="0" anchor="ctr"/>
-          <a:lstStyle/>
-          <a:p>
-            <a:pPr indent="0" marL="0">
-              <a:lnSpc>
-                <a:spcPct val="115000"/>
-              </a:lnSpc>
-              <a:buNone/>
-            </a:pPr>
-            <a:r>
-              <a:rPr lang="en-US" sz="1200" dirty="0">
-                <a:solidFill>
-                  <a:srgbClr val="C9C9E8"/>
-                </a:solidFill>
-                <a:latin typeface="Malgun Gothic" pitchFamily="34" charset="0"/>
-                <a:ea typeface="Malgun Gothic" pitchFamily="34" charset="-122"/>
-                <a:cs typeface="Malgun Gothic" pitchFamily="34" charset="-120"/>
-              </a:rPr>
-              <a:t>앱이 로컬에서 실행하고 결과를 붙인다.</a:t>
-            </a:r>
-            <a:endParaRPr lang="en-US" sz="1200" dirty="0"/>
-          </a:p>
-        </p:txBody>
-      </p:sp>
-      <p:sp>
-        <p:nvSpPr>
-          <p:cNvPr id="20" name="Shape 18"/>
-          <p:cNvSpPr/>
-          <p:nvPr/>
-        </p:nvSpPr>
-        <p:spPr>
-          <a:xfrm>
-            <a:off x="9326880" y="2286000"/>
-            <a:ext cx="2615184" cy="1828800"/>
-          </a:xfrm>
-          <a:prstGeom prst="roundRect">
-            <a:avLst>
-              <a:gd name="adj" fmla="val 5000"/>
-            </a:avLst>
-          </a:prstGeom>
-          <a:solidFill>
-            <a:srgbClr val="22233D"/>
-          </a:solidFill>
-          <a:ln/>
-        </p:spPr>
-      </p:sp>
-      <p:sp>
-        <p:nvSpPr>
-          <p:cNvPr id="21" name="Shape 19"/>
-          <p:cNvSpPr/>
-          <p:nvPr/>
-        </p:nvSpPr>
-        <p:spPr>
-          <a:xfrm>
-            <a:off x="9582912" y="2542032"/>
-            <a:ext cx="548640" cy="548640"/>
-          </a:xfrm>
-          <a:prstGeom prst="ellipse">
-            <a:avLst/>
-          </a:prstGeom>
-          <a:solidFill>
-            <a:srgbClr val="6C5CE7"/>
-          </a:solidFill>
-          <a:ln/>
-        </p:spPr>
-      </p:sp>
-      <p:sp>
-        <p:nvSpPr>
-          <p:cNvPr id="22" name="Text 20"/>
-          <p:cNvSpPr/>
-          <p:nvPr/>
-        </p:nvSpPr>
-        <p:spPr>
-          <a:xfrm>
-            <a:off x="9582912" y="2542032"/>
-            <a:ext cx="548640" cy="548640"/>
-          </a:xfrm>
-          <a:prstGeom prst="rect">
-            <a:avLst/>
-          </a:prstGeom>
-          <a:noFill/>
-          <a:ln/>
-        </p:spPr>
-        <p:txBody>
-          <a:bodyPr wrap="square" lIns="0" tIns="0" rIns="0" bIns="0" rtlCol="0" anchor="ctr"/>
-          <a:lstStyle/>
-          <a:p>
-            <a:pPr algn="ctr" indent="0" marL="0">
-              <a:buNone/>
-            </a:pPr>
-            <a:r>
-              <a:rPr lang="en-US" sz="2200" b="1" dirty="0">
-                <a:solidFill>
-                  <a:srgbClr val="FFFFFF"/>
-                </a:solidFill>
-                <a:latin typeface="Malgun Gothic" pitchFamily="34" charset="0"/>
-                <a:ea typeface="Malgun Gothic" pitchFamily="34" charset="-122"/>
-                <a:cs typeface="Malgun Gothic" pitchFamily="34" charset="-120"/>
-              </a:rPr>
-              <a:t>4</a:t>
-            </a:r>
-            <a:endParaRPr lang="en-US" sz="2200" dirty="0"/>
-          </a:p>
-        </p:txBody>
-      </p:sp>
-      <p:sp>
-        <p:nvSpPr>
-          <p:cNvPr id="23" name="Text 21"/>
-          <p:cNvSpPr/>
-          <p:nvPr/>
-        </p:nvSpPr>
-        <p:spPr>
-          <a:xfrm>
-            <a:off x="9582912" y="3246120"/>
-            <a:ext cx="2157984" cy="365760"/>
-          </a:xfrm>
-          <a:prstGeom prst="rect">
-            <a:avLst/>
-          </a:prstGeom>
-          <a:noFill/>
-          <a:ln/>
-        </p:spPr>
-        <p:txBody>
-          <a:bodyPr wrap="square" lIns="0" tIns="0" rIns="0" bIns="0" rtlCol="0" anchor="ctr"/>
-          <a:lstStyle/>
-          <a:p>
-            <a:pPr indent="0" marL="0">
-              <a:buNone/>
-            </a:pPr>
-            <a:r>
-              <a:rPr lang="en-US" sz="1800" b="1" dirty="0">
-                <a:solidFill>
-                  <a:srgbClr val="FFFFFF"/>
-                </a:solidFill>
-                <a:latin typeface="Malgun Gothic" pitchFamily="34" charset="0"/>
-                <a:ea typeface="Malgun Gothic" pitchFamily="34" charset="-122"/>
-                <a:cs typeface="Malgun Gothic" pitchFamily="34" charset="-120"/>
-              </a:rPr>
-              <a:t>반복</a:t>
-            </a:r>
-            <a:endParaRPr lang="en-US" sz="1800" dirty="0"/>
-          </a:p>
-        </p:txBody>
-      </p:sp>
-      <p:sp>
-        <p:nvSpPr>
-          <p:cNvPr id="24" name="Text 22"/>
-          <p:cNvSpPr/>
-          <p:nvPr/>
-        </p:nvSpPr>
-        <p:spPr>
-          <a:xfrm>
-            <a:off x="9582912" y="3611880"/>
-            <a:ext cx="2157984" cy="457200"/>
-          </a:xfrm>
-          <a:prstGeom prst="rect">
-            <a:avLst/>
-          </a:prstGeom>
-          <a:noFill/>
-          <a:ln/>
-        </p:spPr>
-        <p:txBody>
-          <a:bodyPr wrap="square" lIns="0" tIns="0" rIns="0" bIns="0" rtlCol="0" anchor="ctr"/>
-          <a:lstStyle/>
-          <a:p>
-            <a:pPr indent="0" marL="0">
-              <a:lnSpc>
-                <a:spcPct val="115000"/>
-              </a:lnSpc>
-              <a:buNone/>
-            </a:pPr>
-            <a:r>
-              <a:rPr lang="en-US" sz="1200" dirty="0">
-                <a:solidFill>
-                  <a:srgbClr val="C9C9E8"/>
-                </a:solidFill>
-                <a:latin typeface="Malgun Gothic" pitchFamily="34" charset="0"/>
-                <a:ea typeface="Malgun Gothic" pitchFamily="34" charset="-122"/>
-                <a:cs typeface="Malgun Gothic" pitchFamily="34" charset="-120"/>
-              </a:rPr>
-              <a:t>결과로 다시 질의 — 최대 4라운드.</a:t>
-            </a:r>
-            <a:endParaRPr lang="en-US" sz="1200" dirty="0"/>
-          </a:p>
-        </p:txBody>
-      </p:sp>
-      <p:sp>
-        <p:nvSpPr>
-          <p:cNvPr id="25" name="Shape 23"/>
-          <p:cNvSpPr/>
-          <p:nvPr/>
-        </p:nvSpPr>
-        <p:spPr>
-          <a:xfrm>
-            <a:off x="822960" y="4526280"/>
-            <a:ext cx="2615184" cy="822960"/>
-          </a:xfrm>
-          <a:prstGeom prst="roundRect">
-            <a:avLst>
-              <a:gd name="adj" fmla="val 8889"/>
-            </a:avLst>
-          </a:prstGeom>
-          <a:solidFill>
-            <a:srgbClr val="1E1F36"/>
-          </a:solidFill>
-          <a:ln/>
-        </p:spPr>
-      </p:sp>
-      <p:sp>
-        <p:nvSpPr>
-          <p:cNvPr id="26" name="Text 24"/>
-          <p:cNvSpPr/>
-          <p:nvPr/>
-        </p:nvSpPr>
-        <p:spPr>
-          <a:xfrm>
-            <a:off x="1005840" y="4526280"/>
-            <a:ext cx="2295144" cy="822960"/>
-          </a:xfrm>
-          <a:prstGeom prst="rect">
-            <a:avLst/>
-          </a:prstGeom>
-          <a:noFill/>
-          <a:ln/>
-        </p:spPr>
-        <p:txBody>
-          <a:bodyPr wrap="square" lIns="0" tIns="0" rIns="0" bIns="0" rtlCol="0" anchor="ctr"/>
-          <a:lstStyle/>
-          <a:p>
-            <a:pPr indent="0" marL="0">
-              <a:lnSpc>
-                <a:spcPct val="115000"/>
-              </a:lnSpc>
-              <a:buNone/>
-            </a:pPr>
-            <a:r>
-              <a:rPr lang="en-US" sz="1150" dirty="0">
-                <a:solidFill>
-                  <a:srgbClr val="C9C9E8"/>
-                </a:solidFill>
-                <a:latin typeface="Malgun Gothic" pitchFamily="34" charset="0"/>
-                <a:ea typeface="Malgun Gothic" pitchFamily="34" charset="-122"/>
-                <a:cs typeface="Malgun Gothic" pitchFamily="34" charset="-120"/>
-              </a:rPr>
-              <a:t>scheduleAgent — 일정 초안·규칙</a:t>
-            </a:r>
-            <a:endParaRPr lang="en-US" sz="1150" dirty="0"/>
-          </a:p>
-        </p:txBody>
-      </p:sp>
-      <p:sp>
-        <p:nvSpPr>
-          <p:cNvPr id="27" name="Shape 25"/>
-          <p:cNvSpPr/>
-          <p:nvPr/>
-        </p:nvSpPr>
-        <p:spPr>
-          <a:xfrm>
-            <a:off x="3657600" y="4526280"/>
-            <a:ext cx="2615184" cy="822960"/>
-          </a:xfrm>
-          <a:prstGeom prst="roundRect">
-            <a:avLst>
-              <a:gd name="adj" fmla="val 8889"/>
-            </a:avLst>
-          </a:prstGeom>
-          <a:solidFill>
-            <a:srgbClr val="1E1F36"/>
-          </a:solidFill>
-          <a:ln/>
-        </p:spPr>
-      </p:sp>
-      <p:sp>
-        <p:nvSpPr>
-          <p:cNvPr id="28" name="Text 26"/>
-          <p:cNvSpPr/>
-          <p:nvPr/>
-        </p:nvSpPr>
-        <p:spPr>
-          <a:xfrm>
-            <a:off x="3840480" y="4526280"/>
-            <a:ext cx="2295144" cy="822960"/>
-          </a:xfrm>
-          <a:prstGeom prst="rect">
-            <a:avLst/>
-          </a:prstGeom>
-          <a:noFill/>
-          <a:ln/>
-        </p:spPr>
-        <p:txBody>
-          <a:bodyPr wrap="square" lIns="0" tIns="0" rIns="0" bIns="0" rtlCol="0" anchor="ctr"/>
-          <a:lstStyle/>
-          <a:p>
-            <a:pPr indent="0" marL="0">
-              <a:lnSpc>
-                <a:spcPct val="115000"/>
-              </a:lnSpc>
-              <a:buNone/>
-            </a:pPr>
-            <a:r>
-              <a:rPr lang="en-US" sz="1150" dirty="0">
-                <a:solidFill>
-                  <a:srgbClr val="C9C9E8"/>
-                </a:solidFill>
-                <a:latin typeface="Malgun Gothic" pitchFamily="34" charset="0"/>
-                <a:ea typeface="Malgun Gothic" pitchFamily="34" charset="-122"/>
-                <a:cs typeface="Malgun Gothic" pitchFamily="34" charset="-120"/>
-              </a:rPr>
-              <a:t>qaAgent — 질의응답</a:t>
-            </a:r>
-            <a:endParaRPr lang="en-US" sz="1150" dirty="0"/>
-          </a:p>
-        </p:txBody>
-      </p:sp>
-      <p:sp>
-        <p:nvSpPr>
-          <p:cNvPr id="29" name="Shape 27"/>
-          <p:cNvSpPr/>
-          <p:nvPr/>
-        </p:nvSpPr>
-        <p:spPr>
-          <a:xfrm>
-            <a:off x="6492240" y="4526280"/>
-            <a:ext cx="2615184" cy="822960"/>
-          </a:xfrm>
-          <a:prstGeom prst="roundRect">
-            <a:avLst>
-              <a:gd name="adj" fmla="val 8889"/>
-            </a:avLst>
-          </a:prstGeom>
-          <a:solidFill>
-            <a:srgbClr val="1E1F36"/>
-          </a:solidFill>
-          <a:ln/>
-        </p:spPr>
-      </p:sp>
-      <p:sp>
-        <p:nvSpPr>
-          <p:cNvPr id="30" name="Text 28"/>
-          <p:cNvSpPr/>
-          <p:nvPr/>
-        </p:nvSpPr>
-        <p:spPr>
-          <a:xfrm>
-            <a:off x="6675120" y="4526280"/>
-            <a:ext cx="2295144" cy="822960"/>
-          </a:xfrm>
-          <a:prstGeom prst="rect">
-            <a:avLst/>
-          </a:prstGeom>
-          <a:noFill/>
-          <a:ln/>
-        </p:spPr>
-        <p:txBody>
-          <a:bodyPr wrap="square" lIns="0" tIns="0" rIns="0" bIns="0" rtlCol="0" anchor="ctr"/>
-          <a:lstStyle/>
-          <a:p>
-            <a:pPr indent="0" marL="0">
-              <a:lnSpc>
-                <a:spcPct val="115000"/>
-              </a:lnSpc>
-              <a:buNone/>
-            </a:pPr>
-            <a:r>
-              <a:rPr lang="en-US" sz="1150" dirty="0">
-                <a:solidFill>
-                  <a:srgbClr val="C9C9E8"/>
-                </a:solidFill>
-                <a:latin typeface="Malgun Gothic" pitchFamily="34" charset="0"/>
-                <a:ea typeface="Malgun Gothic" pitchFamily="34" charset="-122"/>
-                <a:cs typeface="Malgun Gothic" pitchFamily="34" charset="-120"/>
-              </a:rPr>
-              <a:t>notesAgent — 편집·요약</a:t>
-            </a:r>
-            <a:endParaRPr lang="en-US" sz="1150" dirty="0"/>
-          </a:p>
-        </p:txBody>
-      </p:sp>
-      <p:sp>
-        <p:nvSpPr>
-          <p:cNvPr id="31" name="Shape 29"/>
-          <p:cNvSpPr/>
-          <p:nvPr/>
-        </p:nvSpPr>
-        <p:spPr>
-          <a:xfrm>
-            <a:off x="9326880" y="4526280"/>
-            <a:ext cx="2615184" cy="822960"/>
-          </a:xfrm>
-          <a:prstGeom prst="roundRect">
-            <a:avLst>
-              <a:gd name="adj" fmla="val 8889"/>
-            </a:avLst>
-          </a:prstGeom>
-          <a:solidFill>
-            <a:srgbClr val="1E1F36"/>
-          </a:solidFill>
-          <a:ln/>
-        </p:spPr>
-      </p:sp>
-      <p:sp>
-        <p:nvSpPr>
-          <p:cNvPr id="32" name="Text 30"/>
-          <p:cNvSpPr/>
-          <p:nvPr/>
-        </p:nvSpPr>
-        <p:spPr>
-          <a:xfrm>
-            <a:off x="9509760" y="4526280"/>
-            <a:ext cx="2295144" cy="822960"/>
-          </a:xfrm>
-          <a:prstGeom prst="rect">
-            <a:avLst/>
-          </a:prstGeom>
-          <a:noFill/>
-          <a:ln/>
-        </p:spPr>
-        <p:txBody>
-          <a:bodyPr wrap="square" lIns="0" tIns="0" rIns="0" bIns="0" rtlCol="0" anchor="ctr"/>
-          <a:lstStyle/>
-          <a:p>
-            <a:pPr indent="0" marL="0">
-              <a:lnSpc>
-                <a:spcPct val="115000"/>
-              </a:lnSpc>
-              <a:buNone/>
-            </a:pPr>
-            <a:r>
-              <a:rPr lang="en-US" sz="1150" dirty="0">
-                <a:solidFill>
-                  <a:srgbClr val="C9C9E8"/>
-                </a:solidFill>
-                <a:latin typeface="Malgun Gothic" pitchFamily="34" charset="0"/>
-                <a:ea typeface="Malgun Gothic" pitchFamily="34" charset="-122"/>
-                <a:cs typeface="Malgun Gothic" pitchFamily="34" charset="-120"/>
-              </a:rPr>
-              <a:t>briefingAgent — 아침 브리핑</a:t>
-            </a:r>
-            <a:endParaRPr lang="en-US" sz="1150" dirty="0"/>
-          </a:p>
-        </p:txBody>
-      </p:sp>
-      <p:sp>
-        <p:nvSpPr>
-          <p:cNvPr id="33" name="Text 31"/>
-          <p:cNvSpPr/>
-          <p:nvPr/>
-        </p:nvSpPr>
-        <p:spPr>
-          <a:xfrm>
-            <a:off x="822960" y="5715000"/>
-            <a:ext cx="10515600" cy="457200"/>
-          </a:xfrm>
-          <a:prstGeom prst="rect">
-            <a:avLst/>
-          </a:prstGeom>
-          <a:noFill/>
-          <a:ln/>
-        </p:spPr>
-        <p:txBody>
-          <a:bodyPr wrap="square" lIns="0" tIns="0" rIns="0" bIns="0" rtlCol="0" anchor="ctr"/>
-          <a:lstStyle/>
-          <a:p>
-            <a:pPr indent="0" marL="0">
-              <a:buNone/>
-            </a:pPr>
-            <a:r>
-              <a:rPr lang="en-US" sz="1400" b="1" dirty="0">
-                <a:solidFill>
-                  <a:srgbClr val="B7ADF7"/>
-                </a:solidFill>
-                <a:latin typeface="Malgun Gothic" pitchFamily="34" charset="0"/>
-                <a:ea typeface="Malgun Gothic" pitchFamily="34" charset="-122"/>
-                <a:cs typeface="Malgun Gothic" pitchFamily="34" charset="-120"/>
-              </a:rPr>
-              <a:t>덕분에 로컬 모델을 포함한 어떤 OpenAI 호환 엔드포인트와도 붙는다.</a:t>
-            </a:r>
-            <a:endParaRPr lang="en-US" sz="1400" dirty="0"/>
-          </a:p>
-        </p:txBody>
-      </p:sp>
-    </p:spTree>
-  </p:cSld>
-  <p:clrMapOvr>
-    <a:masterClrMapping/>
-  </p:clrMapOvr>
-</p:sld>
-</file>
-
-<file path=ppt/slides/slide8.xml><?xml version="1.0" encoding="utf-8"?>
-<p:sld xmlns:a="http://schemas.openxmlformats.org/drawingml/2006/main" xmlns:r="http://schemas.openxmlformats.org/officeDocument/2006/relationships" xmlns:p="http://schemas.openxmlformats.org/presentationml/2006/main">
-  <p:cSld name="Slide 8">
-    <p:bg>
-      <p:bgPr>
-        <a:solidFill>
-          <a:srgbClr val="FFFFFF"/>
-        </a:solidFill>
-      </p:bgPr>
-    </p:bg>
-    <p:spTree>
-      <p:nvGrpSpPr>
-        <p:cNvPr id="1" name=""/>
-        <p:cNvGrpSpPr/>
-        <p:nvPr/>
-      </p:nvGrpSpPr>
-      <p:grpSpPr>
-        <a:xfrm>
-          <a:off x="0" y="0"/>
-          <a:ext cx="0" cy="0"/>
-          <a:chOff x="0" y="0"/>
-          <a:chExt cx="0" cy="0"/>
-        </a:xfrm>
-      </p:grpSpPr>
-      <p:sp>
-        <p:nvSpPr>
-          <p:cNvPr id="2" name="Text 0"/>
-          <p:cNvSpPr/>
-          <p:nvPr/>
-        </p:nvSpPr>
-        <p:spPr>
-          <a:xfrm>
-            <a:off x="822960" y="640080"/>
-            <a:ext cx="5486400" cy="274320"/>
-          </a:xfrm>
-          <a:prstGeom prst="rect">
-            <a:avLst/>
-          </a:prstGeom>
-          <a:noFill/>
-          <a:ln/>
-        </p:spPr>
-        <p:txBody>
-          <a:bodyPr wrap="square" lIns="0" tIns="0" rIns="0" bIns="0" rtlCol="0" anchor="ctr"/>
-          <a:lstStyle/>
-          <a:p>
-            <a:pPr indent="0" marL="0">
-              <a:buNone/>
-            </a:pPr>
-            <a:r>
-              <a:rPr lang="en-US" sz="1100" b="1" spc="300" kern="0" dirty="0">
-                <a:solidFill>
-                  <a:srgbClr val="6C5CE7"/>
-                </a:solidFill>
-                <a:latin typeface="Malgun Gothic" pitchFamily="34" charset="0"/>
-                <a:ea typeface="Malgun Gothic" pitchFamily="34" charset="-122"/>
-                <a:cs typeface="Malgun Gothic" pitchFamily="34" charset="-120"/>
-              </a:rPr>
-              <a:t>DATA &amp; STATS</a:t>
-            </a:r>
-            <a:endParaRPr lang="en-US" sz="1100" dirty="0"/>
-          </a:p>
-        </p:txBody>
-      </p:sp>
-      <p:sp>
-        <p:nvSpPr>
-          <p:cNvPr id="3" name="Text 1"/>
-          <p:cNvSpPr/>
-          <p:nvPr/>
-        </p:nvSpPr>
-        <p:spPr>
-          <a:xfrm>
-            <a:off x="822960" y="914400"/>
-            <a:ext cx="7315200" cy="731520"/>
-          </a:xfrm>
-          <a:prstGeom prst="rect">
-            <a:avLst/>
-          </a:prstGeom>
-          <a:noFill/>
-          <a:ln/>
-        </p:spPr>
-        <p:txBody>
-          <a:bodyPr wrap="square" lIns="0" tIns="0" rIns="0" bIns="0" rtlCol="0" anchor="ctr"/>
-          <a:lstStyle/>
-          <a:p>
-            <a:pPr indent="0" marL="0">
-              <a:buNone/>
-            </a:pPr>
-            <a:r>
-              <a:rPr lang="en-US" sz="3100" b="1" dirty="0">
-                <a:solidFill>
-                  <a:srgbClr val="26263A"/>
-                </a:solidFill>
-                <a:latin typeface="Malgun Gothic" pitchFamily="34" charset="0"/>
-                <a:ea typeface="Malgun Gothic" pitchFamily="34" charset="-122"/>
-                <a:cs typeface="Malgun Gothic" pitchFamily="34" charset="-120"/>
-              </a:rPr>
-              <a:t>내 데이터는 내 브라우저에</a:t>
-            </a:r>
-            <a:endParaRPr lang="en-US" sz="3100" dirty="0"/>
-          </a:p>
-        </p:txBody>
-      </p:sp>
-      <p:sp>
-        <p:nvSpPr>
-          <p:cNvPr id="4" name="Shape 2"/>
-          <p:cNvSpPr/>
-          <p:nvPr/>
-        </p:nvSpPr>
-        <p:spPr>
-          <a:xfrm>
-            <a:off x="822960" y="1965960"/>
-            <a:ext cx="5120640" cy="1051560"/>
-          </a:xfrm>
-          <a:prstGeom prst="roundRect">
-            <a:avLst>
-              <a:gd name="adj" fmla="val 8696"/>
-            </a:avLst>
-          </a:prstGeom>
-          <a:solidFill>
-            <a:srgbClr val="F7F6FE"/>
-          </a:solidFill>
-          <a:ln/>
-        </p:spPr>
-      </p:sp>
-      <p:sp>
-        <p:nvSpPr>
-          <p:cNvPr id="5" name="Shape 3"/>
-          <p:cNvSpPr/>
-          <p:nvPr/>
-        </p:nvSpPr>
-        <p:spPr>
-          <a:xfrm>
-            <a:off x="1051560" y="2203704"/>
-            <a:ext cx="566928" cy="566928"/>
-          </a:xfrm>
-          <a:prstGeom prst="ellipse">
-            <a:avLst/>
-          </a:prstGeom>
-          <a:solidFill>
-            <a:srgbClr val="6C5CE7"/>
-          </a:solidFill>
-          <a:ln/>
-        </p:spPr>
-      </p:sp>
-      <p:pic>
-        <p:nvPicPr>
-          <p:cNvPr id="6" name="Image 0" descr="preencoded.png">    </p:cNvPr>
-          <p:cNvPicPr>
-            <a:picLocks noChangeAspect="1"/>
-          </p:cNvPicPr>
-          <p:nvPr/>
-        </p:nvPicPr>
-        <p:blipFill>
-          <a:blip r:embed="rId1"/>
-          <a:stretch>
-            <a:fillRect/>
-          </a:stretch>
-        </p:blipFill>
-        <p:spPr>
-          <a:xfrm>
-            <a:off x="1198961" y="2351105"/>
-            <a:ext cx="272125" cy="272125"/>
-          </a:xfrm>
-          <a:prstGeom prst="rect">
-            <a:avLst/>
-          </a:prstGeom>
-        </p:spPr>
-      </p:pic>
-      <p:sp>
-        <p:nvSpPr>
-          <p:cNvPr id="7" name="Text 4"/>
-          <p:cNvSpPr/>
-          <p:nvPr/>
-        </p:nvSpPr>
-        <p:spPr>
-          <a:xfrm>
-            <a:off x="1828800" y="2148840"/>
-            <a:ext cx="3931920" cy="365760"/>
-          </a:xfrm>
-          <a:prstGeom prst="rect">
-            <a:avLst/>
-          </a:prstGeom>
-          <a:noFill/>
-          <a:ln/>
-        </p:spPr>
-        <p:txBody>
-          <a:bodyPr wrap="square" lIns="0" tIns="0" rIns="0" bIns="0" rtlCol="0" anchor="ctr"/>
-          <a:lstStyle/>
-          <a:p>
-            <a:pPr indent="0" marL="0">
-              <a:buNone/>
-            </a:pPr>
-            <a:r>
-              <a:rPr lang="en-US" sz="1600" b="1" dirty="0">
-                <a:solidFill>
-                  <a:srgbClr val="26263A"/>
-                </a:solidFill>
-                <a:latin typeface="Malgun Gothic" pitchFamily="34" charset="0"/>
-                <a:ea typeface="Malgun Gothic" pitchFamily="34" charset="-122"/>
-                <a:cs typeface="Malgun Gothic" pitchFamily="34" charset="-120"/>
-              </a:rPr>
-              <a:t>로컬 우선</a:t>
-            </a:r>
-            <a:endParaRPr lang="en-US" sz="1600" dirty="0"/>
-          </a:p>
-        </p:txBody>
-      </p:sp>
-      <p:sp>
-        <p:nvSpPr>
-          <p:cNvPr id="8" name="Text 5"/>
-          <p:cNvSpPr/>
-          <p:nvPr/>
-        </p:nvSpPr>
-        <p:spPr>
-          <a:xfrm>
-            <a:off x="1828800" y="2496312"/>
-            <a:ext cx="3977640" cy="457200"/>
-          </a:xfrm>
-          <a:prstGeom prst="rect">
-            <a:avLst/>
-          </a:prstGeom>
-          <a:noFill/>
-          <a:ln/>
-        </p:spPr>
-        <p:txBody>
-          <a:bodyPr wrap="square" lIns="0" tIns="0" rIns="0" bIns="0" rtlCol="0" anchor="ctr"/>
-          <a:lstStyle/>
-          <a:p>
-            <a:pPr indent="0" marL="0">
-              <a:buNone/>
-            </a:pPr>
-            <a:r>
-              <a:rPr lang="en-US" sz="1250" dirty="0">
-                <a:solidFill>
-                  <a:srgbClr val="6E6E82"/>
-                </a:solidFill>
-                <a:latin typeface="Malgun Gothic" pitchFamily="34" charset="0"/>
-                <a:ea typeface="Malgun Gothic" pitchFamily="34" charset="-122"/>
-                <a:cs typeface="Malgun Gothic" pitchFamily="34" charset="-120"/>
-              </a:rPr>
-              <a:t>모든 데이터는 IndexedDB에. 계정도 서버도 없다.</a:t>
-            </a:r>
-            <a:endParaRPr lang="en-US" sz="1250" dirty="0"/>
-          </a:p>
-        </p:txBody>
-      </p:sp>
-      <p:sp>
-        <p:nvSpPr>
-          <p:cNvPr id="9" name="Shape 6"/>
-          <p:cNvSpPr/>
-          <p:nvPr/>
-        </p:nvSpPr>
-        <p:spPr>
-          <a:xfrm>
-            <a:off x="822960" y="3200400"/>
-            <a:ext cx="5120640" cy="1051560"/>
-          </a:xfrm>
-          <a:prstGeom prst="roundRect">
-            <a:avLst>
-              <a:gd name="adj" fmla="val 8696"/>
-            </a:avLst>
-          </a:prstGeom>
-          <a:solidFill>
-            <a:srgbClr val="F7F6FE"/>
-          </a:solidFill>
-          <a:ln/>
-        </p:spPr>
-      </p:sp>
-      <p:sp>
-        <p:nvSpPr>
-          <p:cNvPr id="10" name="Shape 7"/>
-          <p:cNvSpPr/>
-          <p:nvPr/>
-        </p:nvSpPr>
-        <p:spPr>
-          <a:xfrm>
-            <a:off x="1051560" y="3438144"/>
-            <a:ext cx="566928" cy="566928"/>
-          </a:xfrm>
-          <a:prstGeom prst="ellipse">
-            <a:avLst/>
-          </a:prstGeom>
-          <a:solidFill>
-            <a:srgbClr val="6C5CE7"/>
-          </a:solidFill>
-          <a:ln/>
-        </p:spPr>
-      </p:sp>
-      <p:pic>
-        <p:nvPicPr>
-          <p:cNvPr id="11" name="Image 1" descr="preencoded.png">    </p:cNvPr>
-          <p:cNvPicPr>
-            <a:picLocks noChangeAspect="1"/>
-          </p:cNvPicPr>
-          <p:nvPr/>
-        </p:nvPicPr>
-        <p:blipFill>
-          <a:blip r:embed="rId2"/>
-          <a:stretch>
-            <a:fillRect/>
-          </a:stretch>
-        </p:blipFill>
-        <p:spPr>
-          <a:xfrm>
-            <a:off x="1198961" y="3585545"/>
-            <a:ext cx="272125" cy="272125"/>
-          </a:xfrm>
-          <a:prstGeom prst="rect">
-            <a:avLst/>
-          </a:prstGeom>
-        </p:spPr>
-      </p:pic>
-      <p:sp>
-        <p:nvSpPr>
-          <p:cNvPr id="12" name="Text 8"/>
-          <p:cNvSpPr/>
-          <p:nvPr/>
-        </p:nvSpPr>
-        <p:spPr>
-          <a:xfrm>
-            <a:off x="1828800" y="3383280"/>
-            <a:ext cx="3931920" cy="365760"/>
-          </a:xfrm>
-          <a:prstGeom prst="rect">
-            <a:avLst/>
-          </a:prstGeom>
-          <a:noFill/>
-          <a:ln/>
-        </p:spPr>
-        <p:txBody>
-          <a:bodyPr wrap="square" lIns="0" tIns="0" rIns="0" bIns="0" rtlCol="0" anchor="ctr"/>
-          <a:lstStyle/>
-          <a:p>
-            <a:pPr indent="0" marL="0">
-              <a:buNone/>
-            </a:pPr>
-            <a:r>
-              <a:rPr lang="en-US" sz="1600" b="1" dirty="0">
-                <a:solidFill>
-                  <a:srgbClr val="26263A"/>
-                </a:solidFill>
-                <a:latin typeface="Malgun Gothic" pitchFamily="34" charset="0"/>
-                <a:ea typeface="Malgun Gothic" pitchFamily="34" charset="-122"/>
-                <a:cs typeface="Malgun Gothic" pitchFamily="34" charset="-120"/>
-              </a:rPr>
-              <a:t>JSON 내보내기·되돌리기</a:t>
-            </a:r>
-            <a:endParaRPr lang="en-US" sz="1600" dirty="0"/>
-          </a:p>
-        </p:txBody>
-      </p:sp>
-      <p:sp>
-        <p:nvSpPr>
-          <p:cNvPr id="13" name="Text 9"/>
-          <p:cNvSpPr/>
-          <p:nvPr/>
-        </p:nvSpPr>
-        <p:spPr>
-          <a:xfrm>
-            <a:off x="1828800" y="3730752"/>
-            <a:ext cx="3977640" cy="457200"/>
-          </a:xfrm>
-          <a:prstGeom prst="rect">
-            <a:avLst/>
-          </a:prstGeom>
-          <a:noFill/>
-          <a:ln/>
-        </p:spPr>
-        <p:txBody>
-          <a:bodyPr wrap="square" lIns="0" tIns="0" rIns="0" bIns="0" rtlCol="0" anchor="ctr"/>
-          <a:lstStyle/>
-          <a:p>
-            <a:pPr indent="0" marL="0">
-              <a:buNone/>
-            </a:pPr>
-            <a:r>
-              <a:rPr lang="en-US" sz="1250" dirty="0">
-                <a:solidFill>
-                  <a:srgbClr val="6E6E82"/>
-                </a:solidFill>
-                <a:latin typeface="Malgun Gothic" pitchFamily="34" charset="0"/>
-                <a:ea typeface="Malgun Gothic" pitchFamily="34" charset="-122"/>
-                <a:cs typeface="Malgun Gothic" pitchFamily="34" charset="-120"/>
-              </a:rPr>
-              <a:t>백업과 이전이 파일 하나로 끝난다.</a:t>
-            </a:r>
-            <a:endParaRPr lang="en-US" sz="1250" dirty="0"/>
-          </a:p>
-        </p:txBody>
-      </p:sp>
-      <p:sp>
-        <p:nvSpPr>
-          <p:cNvPr id="14" name="Shape 10"/>
-          <p:cNvSpPr/>
-          <p:nvPr/>
-        </p:nvSpPr>
-        <p:spPr>
-          <a:xfrm>
-            <a:off x="822960" y="4434840"/>
-            <a:ext cx="5120640" cy="1051560"/>
-          </a:xfrm>
-          <a:prstGeom prst="roundRect">
-            <a:avLst>
-              <a:gd name="adj" fmla="val 8696"/>
-            </a:avLst>
-          </a:prstGeom>
-          <a:solidFill>
-            <a:srgbClr val="F7F6FE"/>
-          </a:solidFill>
-          <a:ln/>
-        </p:spPr>
-      </p:sp>
-      <p:sp>
-        <p:nvSpPr>
-          <p:cNvPr id="15" name="Shape 11"/>
-          <p:cNvSpPr/>
-          <p:nvPr/>
-        </p:nvSpPr>
-        <p:spPr>
-          <a:xfrm>
-            <a:off x="1051560" y="4672584"/>
-            <a:ext cx="566928" cy="566928"/>
-          </a:xfrm>
-          <a:prstGeom prst="ellipse">
-            <a:avLst/>
-          </a:prstGeom>
-          <a:solidFill>
-            <a:srgbClr val="6C5CE7"/>
-          </a:solidFill>
-          <a:ln/>
-        </p:spPr>
-      </p:sp>
-      <p:pic>
-        <p:nvPicPr>
-          <p:cNvPr id="16" name="Image 2" descr="preencoded.png">    </p:cNvPr>
-          <p:cNvPicPr>
-            <a:picLocks noChangeAspect="1"/>
-          </p:cNvPicPr>
-          <p:nvPr/>
-        </p:nvPicPr>
-        <p:blipFill>
-          <a:blip r:embed="rId3"/>
-          <a:stretch>
-            <a:fillRect/>
-          </a:stretch>
-        </p:blipFill>
-        <p:spPr>
-          <a:xfrm>
-            <a:off x="1198961" y="4819985"/>
-            <a:ext cx="272125" cy="272125"/>
-          </a:xfrm>
-          <a:prstGeom prst="rect">
-            <a:avLst/>
-          </a:prstGeom>
-        </p:spPr>
-      </p:pic>
-      <p:sp>
-        <p:nvSpPr>
-          <p:cNvPr id="17" name="Text 12"/>
-          <p:cNvSpPr/>
-          <p:nvPr/>
-        </p:nvSpPr>
-        <p:spPr>
-          <a:xfrm>
-            <a:off x="1828800" y="4617720"/>
-            <a:ext cx="3931920" cy="365760"/>
-          </a:xfrm>
-          <a:prstGeom prst="rect">
-            <a:avLst/>
-          </a:prstGeom>
-          <a:noFill/>
-          <a:ln/>
-        </p:spPr>
-        <p:txBody>
-          <a:bodyPr wrap="square" lIns="0" tIns="0" rIns="0" bIns="0" rtlCol="0" anchor="ctr"/>
-          <a:lstStyle/>
-          <a:p>
-            <a:pPr indent="0" marL="0">
-              <a:buNone/>
-            </a:pPr>
-            <a:r>
-              <a:rPr lang="en-US" sz="1600" b="1" dirty="0">
-                <a:solidFill>
-                  <a:srgbClr val="26263A"/>
-                </a:solidFill>
-                <a:latin typeface="Malgun Gothic" pitchFamily="34" charset="0"/>
-                <a:ea typeface="Malgun Gothic" pitchFamily="34" charset="-122"/>
-                <a:cs typeface="Malgun Gothic" pitchFamily="34" charset="-120"/>
-              </a:rPr>
-              <a:t>AI 토큰 집계</a:t>
-            </a:r>
-            <a:endParaRPr lang="en-US" sz="1600" dirty="0"/>
-          </a:p>
-        </p:txBody>
-      </p:sp>
-      <p:sp>
-        <p:nvSpPr>
-          <p:cNvPr id="18" name="Text 13"/>
-          <p:cNvSpPr/>
-          <p:nvPr/>
-        </p:nvSpPr>
-        <p:spPr>
-          <a:xfrm>
-            <a:off x="1828800" y="4965192"/>
-            <a:ext cx="3977640" cy="457200"/>
-          </a:xfrm>
-          <a:prstGeom prst="rect">
-            <a:avLst/>
-          </a:prstGeom>
-          <a:noFill/>
-          <a:ln/>
-        </p:spPr>
-        <p:txBody>
-          <a:bodyPr wrap="square" lIns="0" tIns="0" rIns="0" bIns="0" rtlCol="0" anchor="ctr"/>
-          <a:lstStyle/>
-          <a:p>
-            <a:pPr indent="0" marL="0">
-              <a:buNone/>
-            </a:pPr>
-            <a:r>
-              <a:rPr lang="en-US" sz="1250" dirty="0">
-                <a:solidFill>
-                  <a:srgbClr val="6E6E82"/>
-                </a:solidFill>
-                <a:latin typeface="Malgun Gothic" pitchFamily="34" charset="0"/>
-                <a:ea typeface="Malgun Gothic" pitchFamily="34" charset="-122"/>
-                <a:cs typeface="Malgun Gothic" pitchFamily="34" charset="-120"/>
-              </a:rPr>
-              <a:t>오늘·누적 사용량을 통계 탭에서 확인.</a:t>
-            </a:r>
-            <a:endParaRPr lang="en-US" sz="1250" dirty="0"/>
-          </a:p>
-        </p:txBody>
-      </p:sp>
-      <p:sp>
-        <p:nvSpPr>
-          <p:cNvPr id="19" name="Shape 14"/>
-          <p:cNvSpPr/>
-          <p:nvPr/>
-        </p:nvSpPr>
-        <p:spPr>
-          <a:xfrm>
-            <a:off x="6437376" y="1773936"/>
-            <a:ext cx="6100877" cy="4270248"/>
-          </a:xfrm>
-          <a:prstGeom prst="roundRect">
-            <a:avLst>
-              <a:gd name="adj" fmla="val 1927"/>
-            </a:avLst>
-          </a:prstGeom>
-          <a:solidFill>
-            <a:srgbClr val="FFFFFF"/>
-          </a:solidFill>
-          <a:ln w="12700">
-            <a:solidFill>
-              <a:srgbClr val="E6E4F5"/>
-            </a:solidFill>
-            <a:prstDash val="solid"/>
-          </a:ln>
-          <a:effectLst>
-            <a:outerShdw sx="100000" sy="100000" kx="0" ky="0" algn="bl" rotWithShape="0" blurRad="152400" dist="50800" dir="5400000">
-              <a:srgbClr val="16172A">
-                <a:alpha val="10000"/>
-              </a:srgbClr>
-            </a:outerShdw>
-          </a:effectLst>
-        </p:spPr>
-      </p:sp>
-      <p:pic>
-        <p:nvPicPr>
-          <p:cNvPr id="20" name="Image 3" descr="C:\Users\sohnj\Project\260627 AI Planner 클로드\docs\images\stats.png">    </p:cNvPr>
-          <p:cNvPicPr>
-            <a:picLocks noChangeAspect="1"/>
-          </p:cNvPicPr>
-          <p:nvPr/>
-        </p:nvPicPr>
-        <p:blipFill>
-          <a:blip r:embed="rId4"/>
-          <a:stretch>
-            <a:fillRect/>
-          </a:stretch>
-        </p:blipFill>
-        <p:spPr>
-          <a:xfrm>
-            <a:off x="6492240" y="1828800"/>
-            <a:ext cx="5991149" cy="4160520"/>
-          </a:xfrm>
-          <a:prstGeom prst="rect">
-            <a:avLst/>
-          </a:prstGeom>
-        </p:spPr>
-      </p:pic>
-    </p:spTree>
-  </p:cSld>
-  <p:clrMapOvr>
-    <a:masterClrMapping/>
-  </p:clrMapOvr>
-</p:sld>
-</file>
-
-<file path=ppt/slides/slide9.xml><?xml version="1.0" encoding="utf-8"?>
-<p:sld xmlns:a="http://schemas.openxmlformats.org/drawingml/2006/main" xmlns:r="http://schemas.openxmlformats.org/officeDocument/2006/relationships" xmlns:p="http://schemas.openxmlformats.org/presentationml/2006/main">
-  <p:cSld name="Slide 9">
-    <p:bg>
-      <p:bgPr>
-        <a:solidFill>
-          <a:srgbClr val="16172A"/>
-        </a:solidFill>
-      </p:bgPr>
-    </p:bg>
-    <p:spTree>
-      <p:nvGrpSpPr>
-        <p:cNvPr id="1" name=""/>
-        <p:cNvGrpSpPr/>
-        <p:nvPr/>
-      </p:nvGrpSpPr>
-      <p:grpSpPr>
-        <a:xfrm>
-          <a:off x="0" y="0"/>
-          <a:ext cx="0" cy="0"/>
-          <a:chOff x="0" y="0"/>
-          <a:chExt cx="0" cy="0"/>
-        </a:xfrm>
-      </p:grpSpPr>
-      <p:sp>
-        <p:nvSpPr>
           <p:cNvPr id="2" name="Shape 0"/>
           <p:cNvSpPr/>
           <p:nvPr/>
@@ -6562,8 +5362,8 @@
         </p:nvSpPr>
         <p:spPr>
           <a:xfrm>
-            <a:off x="1097280" y="2331720"/>
-            <a:ext cx="10058400" cy="1645920"/>
+            <a:off x="1097280" y="2194560"/>
+            <a:ext cx="10424160" cy="1828800"/>
           </a:xfrm>
           <a:prstGeom prst="rect">
             <a:avLst/>
@@ -6577,12 +5377,12 @@
           <a:p>
             <a:pPr indent="0" marL="0">
               <a:lnSpc>
-                <a:spcPct val="125000"/>
+                <a:spcPct val="132000"/>
               </a:lnSpc>
               <a:buNone/>
             </a:pPr>
             <a:r>
-              <a:rPr lang="en-US" sz="3400" b="1" dirty="0">
+              <a:rPr lang="en-US" sz="3200" b="1" dirty="0">
                 <a:solidFill>
                   <a:srgbClr val="FFFFFF"/>
                 </a:solidFill>
@@ -6590,16 +5390,16 @@
                 <a:ea typeface="Malgun Gothic" pitchFamily="34" charset="-122"/>
                 <a:cs typeface="Malgun Gothic" pitchFamily="34" charset="-120"/>
               </a:rPr>
-              <a:t>로컬에 남고, </a:t>
+              <a:t>쪽지는 </a:t>
             </a:r>
             <a:pPr indent="0" marL="0">
               <a:lnSpc>
-                <a:spcPct val="125000"/>
+                <a:spcPct val="132000"/>
               </a:lnSpc>
               <a:buNone/>
             </a:pPr>
             <a:r>
-              <a:rPr lang="en-US" sz="3400" b="1" dirty="0">
+              <a:rPr lang="en-US" sz="3200" b="1" dirty="0">
                 <a:solidFill>
                   <a:srgbClr val="B7ADF7"/>
                 </a:solidFill>
@@ -6607,16 +5407,16 @@
                 <a:ea typeface="Malgun Gothic" pitchFamily="34" charset="-122"/>
                 <a:cs typeface="Malgun Gothic" pitchFamily="34" charset="-120"/>
               </a:rPr>
-              <a:t>자연어로 움직이고, </a:t>
+              <a:t>정리되고</a:t>
             </a:r>
             <a:pPr indent="0" marL="0">
               <a:lnSpc>
-                <a:spcPct val="125000"/>
+                <a:spcPct val="132000"/>
               </a:lnSpc>
               <a:buNone/>
             </a:pPr>
             <a:r>
-              <a:rPr lang="en-US" sz="3400" b="1" dirty="0">
+              <a:rPr lang="en-US" sz="3200" b="1" dirty="0">
                 <a:solidFill>
                   <a:srgbClr val="FFFFFF"/>
                 </a:solidFill>
@@ -6624,9 +5424,97 @@
                 <a:ea typeface="Malgun Gothic" pitchFamily="34" charset="-122"/>
                 <a:cs typeface="Malgun Gothic" pitchFamily="34" charset="-120"/>
               </a:rPr>
-              <a:t>반복은 스스로 학습한다.</a:t>
-            </a:r>
-            <a:endParaRPr lang="en-US" sz="3400" dirty="0"/>
+              <a:t>, 마감은 </a:t>
+            </a:r>
+            <a:pPr indent="0" marL="0">
+              <a:lnSpc>
+                <a:spcPct val="132000"/>
+              </a:lnSpc>
+              <a:buNone/>
+            </a:pPr>
+            <a:r>
+              <a:rPr lang="en-US" sz="3200" b="1" dirty="0">
+                <a:solidFill>
+                  <a:srgbClr val="B7ADF7"/>
+                </a:solidFill>
+                <a:latin typeface="Malgun Gothic" pitchFamily="34" charset="0"/>
+                <a:ea typeface="Malgun Gothic" pitchFamily="34" charset="-122"/>
+                <a:cs typeface="Malgun Gothic" pitchFamily="34" charset="-120"/>
+              </a:rPr>
+              <a:t>먼저 보이고</a:t>
+            </a:r>
+            <a:pPr indent="0" marL="0">
+              <a:lnSpc>
+                <a:spcPct val="132000"/>
+              </a:lnSpc>
+              <a:buNone/>
+            </a:pPr>
+            <a:r>
+              <a:rPr lang="en-US" sz="3200" b="1" dirty="0">
+                <a:solidFill>
+                  <a:srgbClr val="FFFFFF"/>
+                </a:solidFill>
+                <a:latin typeface="Malgun Gothic" pitchFamily="34" charset="0"/>
+                <a:ea typeface="Malgun Gothic" pitchFamily="34" charset="-122"/>
+                <a:cs typeface="Malgun Gothic" pitchFamily="34" charset="-120"/>
+              </a:rPr>
+              <a:t>,</a:t>
+            </a:r>
+            <a:endParaRPr lang="en-US" sz="3200" dirty="0"/>
+          </a:p>
+          <a:p>
+            <a:pPr indent="0" marL="0">
+              <a:lnSpc>
+                <a:spcPct val="132000"/>
+              </a:lnSpc>
+              <a:buNone/>
+            </a:pPr>
+            <a:r>
+              <a:rPr lang="en-US" sz="3200" b="1" dirty="0">
+                <a:solidFill>
+                  <a:srgbClr val="FFFFFF"/>
+                </a:solidFill>
+                <a:latin typeface="Malgun Gothic" pitchFamily="34" charset="0"/>
+                <a:ea typeface="Malgun Gothic" pitchFamily="34" charset="-122"/>
+                <a:cs typeface="Malgun Gothic" pitchFamily="34" charset="-120"/>
+              </a:rPr>
+              <a:t>찾을 땐 </a:t>
+            </a:r>
+            <a:pPr indent="0" marL="0">
+              <a:lnSpc>
+                <a:spcPct val="132000"/>
+              </a:lnSpc>
+              <a:buNone/>
+            </a:pPr>
+            <a:r>
+              <a:rPr lang="en-US" sz="3200" b="1" dirty="0">
+                <a:solidFill>
+                  <a:srgbClr val="B7ADF7"/>
+                </a:solidFill>
+                <a:latin typeface="Malgun Gothic" pitchFamily="34" charset="0"/>
+                <a:ea typeface="Malgun Gothic" pitchFamily="34" charset="-122"/>
+                <a:cs typeface="Malgun Gothic" pitchFamily="34" charset="-120"/>
+              </a:rPr>
+              <a:t>물어본다</a:t>
+            </a:r>
+            <a:pPr indent="0" marL="0">
+              <a:lnSpc>
+                <a:spcPct val="132000"/>
+              </a:lnSpc>
+              <a:buNone/>
+            </a:pPr>
+            <a:r>
+              <a:rPr lang="en-US" sz="3200" b="1" dirty="0">
+                <a:solidFill>
+                  <a:srgbClr val="FFFFFF"/>
+                </a:solidFill>
+                <a:latin typeface="Malgun Gothic" pitchFamily="34" charset="0"/>
+                <a:ea typeface="Malgun Gothic" pitchFamily="34" charset="-122"/>
+                <a:cs typeface="Malgun Gothic" pitchFamily="34" charset="-120"/>
+              </a:rPr>
+              <a:t>.</a:t>
+            </a:r>
+            <a:endParaRPr lang="en-US" sz="3200" dirty="0"/>
           </a:p>
         </p:txBody>
       </p:sp>
@@ -6638,7 +5526,7 @@
         </p:nvSpPr>
         <p:spPr>
           <a:xfrm>
-            <a:off x="1097280" y="4114800"/>
+            <a:off x="1097280" y="4160520"/>
             <a:ext cx="5486400" cy="640080"/>
           </a:xfrm>
           <a:prstGeom prst="rect">
@@ -6677,7 +5565,7 @@
         </p:nvSpPr>
         <p:spPr>
           <a:xfrm>
-            <a:off x="1097280" y="4800600"/>
+            <a:off x="1097280" y="4846320"/>
             <a:ext cx="8229600" cy="365760"/>
           </a:xfrm>
           <a:prstGeom prst="rect">

</xml_diff>